<commit_message>
Deck: update test numbers (23 contract tests incl. fuzz, 12 unit, 15 e2e)
Co-Authored-By: Claude Opus 5.5 <noreply@anthropic.com>
</commit_message>
<xml_diff>
--- a/deck/KRIYA-pitch.pptx
+++ b/deck/KRIYA-pitch.pptx
@@ -121,14 +121,14 @@
   <p:extLst>
     <p:ext uri="{521415D9-36F7-43E2-AB2F-B90AF26B5E84}">
       <p14:sectionLst xmlns:p14="http://schemas.microsoft.com/office/powerpoint/2010/main">
-        <p14:section name="Why capital needs programmable objectives" id="{a2a8159e-68dc-b6b9-0428-e00dcad03f67}">
+        <p14:section name="Why capital needs programmable objectives" id="{4e82c3c8-62f5-bdbb-8cf7-57b9f1b40171}">
           <p14:sldIdLst>
             <p14:sldId id="256"/>
             <p14:sldId id="257"/>
             <p14:sldId id="258"/>
           </p14:sldIdLst>
         </p14:section>
-        <p14:section name="How KRIYA turns a mandate into bounded autonomous execution" id="{ec52341d-57c6-150a-2531-bd38ed9badf2}">
+        <p14:section name="How KRIYA turns a mandate into bounded autonomous execution" id="{5b22590e-143c-bf69-ee46-6c7a758f1800}">
           <p14:sldIdLst>
             <p14:sldId id="259"/>
             <p14:sldId id="260"/>
@@ -136,7 +136,7 @@
             <p14:sldId id="262"/>
           </p14:sldIdLst>
         </p14:section>
-        <p14:section name="The working loop, live on Ethereum Sepolia" id="{c5812fac-8170-4a1f-b1cf-81a1fc918755}">
+        <p14:section name="The working loop, live on Ethereum Sepolia" id="{9c0b630c-c575-c1cd-284e-938a33a3524e}">
           <p14:sldIdLst>
             <p14:sldId id="263"/>
             <p14:sldId id="264"/>
@@ -144,7 +144,7 @@
             <p14:sldId id="266"/>
           </p14:sldIdLst>
         </p14:section>
-        <p14:section name="Why it matters and where it goes" id="{b9cd6fc7-5e75-0e7b-2c26-00baf68aaa12}">
+        <p14:section name="Why it matters and where it goes" id="{a390676a-4960-e023-76bf-408ffe5a5b11}">
           <p14:sldIdLst>
             <p14:sldId id="267"/>
             <p14:sldId id="268"/>
@@ -732,7 +732,7 @@
           <a:p>
             <a:r>
               <a:rPr lang="en-US" dirty="0"/>
-              <a:t>We built one polished vertical slice rather than five disconnected integrations: contracts with tests, the Chainlink CRE workflow, a Claude decision engine whose output is always validated, and a live app on Vercel against Sepolia.</a:t>
+              <a:t>We built one polished vertical slice rather than five disconnected integrations: contracts with 23 tests including fuzzing, the Chainlink CRE workflow, a Claude decision engine whose output is always validated, and a live app on Vercel against Sepolia.</a:t>
             </a:r>
             <a:endParaRPr lang="en-US" dirty="0"/>
           </a:p>
@@ -3808,7 +3808,7 @@
                   <a:srgbClr val="9AA8BA"/>
                 </a:solidFill>
               </a:rPr>
-              <a:t>Vault, Mandate, Executor, Strategy Registry. Foundry, 17 passing tests.</a:t>
+              <a:t>Vault, Mandate, Executor, Registry. 23 Foundry tests, incl. 1,000-run fuzz.</a:t>
             </a:r>
             <a:endParaRPr lang="en-US" sz="1300" dirty="0"/>
           </a:p>
@@ -4291,7 +4291,7 @@
                   <a:srgbClr val="9AA8BA"/>
                 </a:solidFill>
               </a:rPr>
-              <a:t>Next.js on Vercel, wallet flows, risk feed, decision journal.</a:t>
+              <a:t>Next.js on Vercel. 12 unit + 15 end-to-end tests, all in CI.</a:t>
             </a:r>
             <a:endParaRPr lang="en-US" sz="1300" dirty="0"/>
           </a:p>
@@ -5930,7 +5930,7 @@
                             <a:srgbClr val="4A5568"/>
                           </a:solidFill>
                         </a:rPr>
-                        <a:t>Vault, Mandate, Executor, Registry · 17 tests</a:t>
+                        <a:t>4 contracts · 23 tests incl. fuzzing</a:t>
                       </a:r>
                       <a:endParaRPr lang="en-US" sz="1400" dirty="0"/>
                     </a:p>
@@ -6302,7 +6302,7 @@
                             <a:srgbClr val="4A5568"/>
                           </a:solidFill>
                         </a:rPr>
-                        <a:t>Dashboard, wallet flows, Sepolia deploy</a:t>
+                        <a:t>Live app · 15 end-to-end checks in CI</a:t>
                       </a:r>
                       <a:endParaRPr lang="en-US" sz="1400" dirty="0"/>
                     </a:p>

</xml_diff>

<commit_message>
Deck: live mission-control screenshot on the dashboard slide
Co-Authored-By: Claude Opus 5.5 <noreply@anthropic.com>
</commit_message>
<xml_diff>
--- a/deck/KRIYA-pitch.pptx
+++ b/deck/KRIYA-pitch.pptx
@@ -121,14 +121,14 @@
   <p:extLst>
     <p:ext uri="{521415D9-36F7-43E2-AB2F-B90AF26B5E84}">
       <p14:sectionLst xmlns:p14="http://schemas.microsoft.com/office/powerpoint/2010/main">
-        <p14:section name="Why capital needs programmable objectives" id="{4e82c3c8-62f5-bdbb-8cf7-57b9f1b40171}">
+        <p14:section name="Why capital needs programmable objectives" id="{b85ab5bf-5e6c-d3fe-d5eb-c0fd1503a0e8}">
           <p14:sldIdLst>
             <p14:sldId id="256"/>
             <p14:sldId id="257"/>
             <p14:sldId id="258"/>
           </p14:sldIdLst>
         </p14:section>
-        <p14:section name="How KRIYA turns a mandate into bounded autonomous execution" id="{5b22590e-143c-bf69-ee46-6c7a758f1800}">
+        <p14:section name="How KRIYA turns a mandate into bounded autonomous execution" id="{5047b94c-982c-0165-267a-12080280365e}">
           <p14:sldIdLst>
             <p14:sldId id="259"/>
             <p14:sldId id="260"/>
@@ -136,7 +136,7 @@
             <p14:sldId id="262"/>
           </p14:sldIdLst>
         </p14:section>
-        <p14:section name="The working loop, live on Ethereum Sepolia" id="{9c0b630c-c575-c1cd-284e-938a33a3524e}">
+        <p14:section name="The working loop, live on Ethereum Sepolia" id="{7db8ad74-2760-c7bd-4601-083089448ad5}">
           <p14:sldIdLst>
             <p14:sldId id="263"/>
             <p14:sldId id="264"/>
@@ -144,7 +144,7 @@
             <p14:sldId id="266"/>
           </p14:sldIdLst>
         </p14:section>
-        <p14:section name="Why it matters and where it goes" id="{a390676a-4960-e023-76bf-408ffe5a5b11}">
+        <p14:section name="Why it matters and where it goes" id="{09473149-a24a-c28b-b116-2e172f2186e4}">
           <p14:sldIdLst>
             <p14:sldId id="267"/>
             <p14:sldId id="268"/>
@@ -1788,7 +1788,7 @@
           <a:p>
             <a:r>
               <a:rPr lang="en-US" dirty="0"/>
-              <a:t>This is the dashboard judges can open themselves. Capital, expected yield, risk against the mandate limit, mandate status, the allocation, and an activity log that interleaves onchain events with the agent's decisions, each linked to Etherscan.</a:t>
+              <a:t>This is the real product, live on Sepolia, captured right after an autonomous rebalance. Strategy C's verified risk jumped to 45, over the mandate's limit of 40. The loop verified it onchain, Claude decided to exit C, the policy check passed, and the executor rebalanced: portfolio risk is now 9 of 40. Every step in the pipeline links to its transaction, and the stage bar shows the demo is complete.</a:t>
             </a:r>
             <a:endParaRPr lang="en-US" dirty="0"/>
           </a:p>
@@ -12502,14 +12502,14 @@
       </p:grpSpPr>
       <p:sp>
         <p:nvSpPr>
-          <p:cNvPr id="2" name="Text 0"/>
+          <p:cNvPr id="2" name="Eyebrow"/>
           <p:cNvSpPr txBox="1"/>
           <p:nvPr/>
         </p:nvSpPr>
         <p:spPr>
           <a:xfrm>
-            <a:off x="812800" y="609600"/>
-            <a:ext cx="3810000" cy="444500"/>
+            <a:off x="812800" y="1270000"/>
+            <a:ext cx="2794000" cy="228600"/>
           </a:xfrm>
           <a:prstGeom prst="rect">
             <a:avLst/>
@@ -12525,57 +12525,15 @@
               <a:buNone/>
             </a:pPr>
             <a:r>
-              <a:rPr lang="en-US" sz="2800" b="1" spc="1200" kern="0" dirty="0">
-                <a:solidFill>
-                  <a:srgbClr val="EEF2F6"/>
-                </a:solidFill>
-              </a:rPr>
-              <a:t>KRIYA</a:t>
-            </a:r>
-            <a:endParaRPr lang="en-US" sz="2800" dirty="0"/>
-          </a:p>
-        </p:txBody>
-      </p:sp>
-      <p:sp>
-        <p:nvSpPr>
-          <p:cNvPr id="3" name="Text 1"/>
-          <p:cNvSpPr txBox="1"/>
-          <p:nvPr/>
-        </p:nvSpPr>
-        <p:spPr>
-          <a:xfrm>
-            <a:off x="8966200" y="673100"/>
-            <a:ext cx="2413000" cy="317500"/>
-          </a:xfrm>
-          <a:prstGeom prst="roundRect">
-            <a:avLst>
-              <a:gd name="adj" fmla="val 50000"/>
-            </a:avLst>
-          </a:prstGeom>
-          <a:noFill/>
-          <a:ln w="9525">
-            <a:solidFill>
-              <a:srgbClr val="1F2733"/>
-            </a:solidFill>
-          </a:ln>
-        </p:spPr>
-        <p:txBody>
-          <a:bodyPr wrap="square" lIns="0" tIns="0" rIns="0" bIns="0" rtlCol="0" anchor="ctr"/>
-          <a:lstStyle/>
-          <a:p>
-            <a:pPr algn="ctr" indent="0" marL="0">
-              <a:buNone/>
-            </a:pPr>
-            <a:r>
-              <a:rPr lang="en-US" sz="1200" dirty="0">
-                <a:solidFill>
-                  <a:srgbClr val="8592A6"/>
+              <a:rPr lang="en-US" sz="1200" spc="150" kern="0" dirty="0">
+                <a:solidFill>
+                  <a:schemeClr val="accent1"/>
                 </a:solidFill>
                 <a:latin typeface="Courier New" pitchFamily="34" charset="0"/>
                 <a:ea typeface="Courier New" pitchFamily="34" charset="-122"/>
                 <a:cs typeface="Courier New" pitchFamily="34" charset="-120"/>
               </a:rPr>
-              <a:t>Sepolia · live dashboard</a:t>
+              <a:t>LIVE DASHBOARD · SEPOLIA</a:t>
             </a:r>
             <a:endParaRPr lang="en-US" sz="1200" dirty="0"/>
           </a:p>
@@ -12583,504 +12541,55 @@
       </p:sp>
       <p:sp>
         <p:nvSpPr>
-          <p:cNvPr id="4" name="Capital stat"/>
+          <p:cNvPr id="3" name="Title"/>
+          <p:cNvSpPr txBox="1"/>
+          <p:nvPr/>
+        </p:nvSpPr>
+        <p:spPr>
+          <a:xfrm>
+            <a:off x="812800" y="1587500"/>
+            <a:ext cx="2794000" cy="1143000"/>
+          </a:xfrm>
+          <a:prstGeom prst="rect">
+            <a:avLst/>
+          </a:prstGeom>
+          <a:noFill/>
+          <a:ln/>
+        </p:spPr>
+        <p:txBody>
+          <a:bodyPr wrap="square" lIns="0" tIns="0" rIns="0" bIns="0" rtlCol="0" anchor="t"/>
+          <a:lstStyle/>
+          <a:p>
+            <a:pPr algn="l" indent="0" marL="0">
+              <a:lnSpc>
+                <a:spcPct val="105000"/>
+              </a:lnSpc>
+              <a:buNone/>
+            </a:pPr>
+            <a:r>
+              <a:rPr lang="en-US" sz="3600" b="1" dirty="0">
+                <a:solidFill>
+                  <a:srgbClr val="EEF2F6"/>
+                </a:solidFill>
+              </a:rPr>
+              <a:t>Mission control</a:t>
+            </a:r>
+            <a:endParaRPr lang="en-US" sz="3600" dirty="0"/>
+          </a:p>
+        </p:txBody>
+      </p:sp>
+      <p:sp>
+        <p:nvSpPr>
+          <p:cNvPr id="4" name="Point 1 dot"/>
           <p:cNvSpPr/>
           <p:nvPr/>
         </p:nvSpPr>
         <p:spPr>
           <a:xfrm>
-            <a:off x="812800" y="1333500"/>
-            <a:ext cx="2527300" cy="952500"/>
-          </a:xfrm>
-          <a:prstGeom prst="roundRect">
-            <a:avLst>
-              <a:gd name="adj" fmla="val 10667"/>
-            </a:avLst>
-          </a:prstGeom>
-          <a:solidFill>
-            <a:srgbClr val="0E1218"/>
-          </a:solidFill>
-          <a:ln w="9525">
-            <a:solidFill>
-              <a:srgbClr val="1F2733"/>
-            </a:solidFill>
-            <a:prstDash val="solid"/>
-          </a:ln>
-        </p:spPr>
-      </p:sp>
-      <p:sp>
-        <p:nvSpPr>
-          <p:cNvPr id="5" name="Text 3"/>
-          <p:cNvSpPr txBox="1"/>
-          <p:nvPr/>
-        </p:nvSpPr>
-        <p:spPr>
-          <a:xfrm>
-            <a:off x="990600" y="1498600"/>
-            <a:ext cx="2171700" cy="215900"/>
-          </a:xfrm>
-          <a:prstGeom prst="rect">
-            <a:avLst/>
-          </a:prstGeom>
-          <a:noFill/>
-          <a:ln/>
-        </p:spPr>
-        <p:txBody>
-          <a:bodyPr wrap="square" lIns="0" tIns="0" rIns="0" bIns="0" rtlCol="0" anchor="t"/>
-          <a:lstStyle/>
-          <a:p>
-            <a:pPr algn="l" indent="0" marL="0">
-              <a:buNone/>
-            </a:pPr>
-            <a:r>
-              <a:rPr lang="en-US" sz="1200" dirty="0">
-                <a:solidFill>
-                  <a:srgbClr val="8592A6"/>
-                </a:solidFill>
-              </a:rPr>
-              <a:t>Capital</a:t>
-            </a:r>
-            <a:endParaRPr lang="en-US" sz="1200" dirty="0"/>
-          </a:p>
-        </p:txBody>
-      </p:sp>
-      <p:sp>
-        <p:nvSpPr>
-          <p:cNvPr id="6" name="Text 4"/>
-          <p:cNvSpPr txBox="1"/>
-          <p:nvPr/>
-        </p:nvSpPr>
-        <p:spPr>
-          <a:xfrm>
-            <a:off x="990600" y="1778000"/>
-            <a:ext cx="2171700" cy="381000"/>
-          </a:xfrm>
-          <a:prstGeom prst="rect">
-            <a:avLst/>
-          </a:prstGeom>
-          <a:noFill/>
-          <a:ln/>
-        </p:spPr>
-        <p:txBody>
-          <a:bodyPr wrap="square" lIns="0" tIns="0" rIns="0" bIns="0" rtlCol="0" anchor="t"/>
-          <a:lstStyle/>
-          <a:p>
-            <a:pPr algn="l" indent="0" marL="0">
-              <a:buNone/>
-            </a:pPr>
-            <a:r>
-              <a:rPr lang="en-US" sz="2200" dirty="0">
-                <a:solidFill>
-                  <a:srgbClr val="EEF2F6"/>
-                </a:solidFill>
-                <a:latin typeface="Courier New" pitchFamily="34" charset="0"/>
-                <a:ea typeface="Courier New" pitchFamily="34" charset="-122"/>
-                <a:cs typeface="Courier New" pitchFamily="34" charset="-120"/>
-              </a:rPr>
-              <a:t>$1,000.00</a:t>
-            </a:r>
-            <a:endParaRPr lang="en-US" sz="2200" dirty="0"/>
-          </a:p>
-        </p:txBody>
-      </p:sp>
-      <p:sp>
-        <p:nvSpPr>
-          <p:cNvPr id="7" name="Expected yield stat"/>
-          <p:cNvSpPr/>
-          <p:nvPr/>
-        </p:nvSpPr>
-        <p:spPr>
-          <a:xfrm>
-            <a:off x="3492500" y="1333500"/>
-            <a:ext cx="2527300" cy="952500"/>
-          </a:xfrm>
-          <a:prstGeom prst="roundRect">
-            <a:avLst>
-              <a:gd name="adj" fmla="val 10667"/>
-            </a:avLst>
-          </a:prstGeom>
-          <a:solidFill>
-            <a:srgbClr val="0E1218"/>
-          </a:solidFill>
-          <a:ln w="9525">
-            <a:solidFill>
-              <a:srgbClr val="1F2733"/>
-            </a:solidFill>
-            <a:prstDash val="solid"/>
-          </a:ln>
-        </p:spPr>
-      </p:sp>
-      <p:sp>
-        <p:nvSpPr>
-          <p:cNvPr id="8" name="Text 6"/>
-          <p:cNvSpPr txBox="1"/>
-          <p:nvPr/>
-        </p:nvSpPr>
-        <p:spPr>
-          <a:xfrm>
-            <a:off x="3670300" y="1498600"/>
-            <a:ext cx="2171700" cy="215900"/>
-          </a:xfrm>
-          <a:prstGeom prst="rect">
-            <a:avLst/>
-          </a:prstGeom>
-          <a:noFill/>
-          <a:ln/>
-        </p:spPr>
-        <p:txBody>
-          <a:bodyPr wrap="square" lIns="0" tIns="0" rIns="0" bIns="0" rtlCol="0" anchor="t"/>
-          <a:lstStyle/>
-          <a:p>
-            <a:pPr algn="l" indent="0" marL="0">
-              <a:buNone/>
-            </a:pPr>
-            <a:r>
-              <a:rPr lang="en-US" sz="1200" dirty="0">
-                <a:solidFill>
-                  <a:srgbClr val="8592A6"/>
-                </a:solidFill>
-              </a:rPr>
-              <a:t>Expected yield</a:t>
-            </a:r>
-            <a:endParaRPr lang="en-US" sz="1200" dirty="0"/>
-          </a:p>
-        </p:txBody>
-      </p:sp>
-      <p:sp>
-        <p:nvSpPr>
-          <p:cNvPr id="9" name="Text 7"/>
-          <p:cNvSpPr txBox="1"/>
-          <p:nvPr/>
-        </p:nvSpPr>
-        <p:spPr>
-          <a:xfrm>
-            <a:off x="3670300" y="1778000"/>
-            <a:ext cx="2171700" cy="381000"/>
-          </a:xfrm>
-          <a:prstGeom prst="rect">
-            <a:avLst/>
-          </a:prstGeom>
-          <a:noFill/>
-          <a:ln/>
-        </p:spPr>
-        <p:txBody>
-          <a:bodyPr wrap="square" lIns="0" tIns="0" rIns="0" bIns="0" rtlCol="0" anchor="t"/>
-          <a:lstStyle/>
-          <a:p>
-            <a:pPr algn="l" indent="0" marL="0">
-              <a:buNone/>
-            </a:pPr>
-            <a:r>
-              <a:rPr lang="en-US" sz="2200" dirty="0">
-                <a:solidFill>
-                  <a:srgbClr val="EEF2F6"/>
-                </a:solidFill>
-                <a:latin typeface="Courier New" pitchFamily="34" charset="0"/>
-                <a:ea typeface="Courier New" pitchFamily="34" charset="-122"/>
-                <a:cs typeface="Courier New" pitchFamily="34" charset="-120"/>
-              </a:rPr>
-              <a:t>7.42%</a:t>
-            </a:r>
-            <a:endParaRPr lang="en-US" sz="2200" dirty="0"/>
-          </a:p>
-        </p:txBody>
-      </p:sp>
-      <p:sp>
-        <p:nvSpPr>
-          <p:cNvPr id="10" name="Risk stat"/>
-          <p:cNvSpPr/>
-          <p:nvPr/>
-        </p:nvSpPr>
-        <p:spPr>
-          <a:xfrm>
-            <a:off x="6172200" y="1333500"/>
-            <a:ext cx="2527300" cy="952500"/>
-          </a:xfrm>
-          <a:prstGeom prst="roundRect">
-            <a:avLst>
-              <a:gd name="adj" fmla="val 10667"/>
-            </a:avLst>
-          </a:prstGeom>
-          <a:solidFill>
-            <a:srgbClr val="0E1218"/>
-          </a:solidFill>
-          <a:ln w="9525">
-            <a:solidFill>
-              <a:srgbClr val="1F2733"/>
-            </a:solidFill>
-            <a:prstDash val="solid"/>
-          </a:ln>
-        </p:spPr>
-      </p:sp>
-      <p:sp>
-        <p:nvSpPr>
-          <p:cNvPr id="11" name="Text 9"/>
-          <p:cNvSpPr txBox="1"/>
-          <p:nvPr/>
-        </p:nvSpPr>
-        <p:spPr>
-          <a:xfrm>
-            <a:off x="6350000" y="1498600"/>
-            <a:ext cx="2171700" cy="215900"/>
-          </a:xfrm>
-          <a:prstGeom prst="rect">
-            <a:avLst/>
-          </a:prstGeom>
-          <a:noFill/>
-          <a:ln/>
-        </p:spPr>
-        <p:txBody>
-          <a:bodyPr wrap="square" lIns="0" tIns="0" rIns="0" bIns="0" rtlCol="0" anchor="t"/>
-          <a:lstStyle/>
-          <a:p>
-            <a:pPr algn="l" indent="0" marL="0">
-              <a:buNone/>
-            </a:pPr>
-            <a:r>
-              <a:rPr lang="en-US" sz="1200" dirty="0">
-                <a:solidFill>
-                  <a:srgbClr val="8592A6"/>
-                </a:solidFill>
-              </a:rPr>
-              <a:t>Risk</a:t>
-            </a:r>
-            <a:endParaRPr lang="en-US" sz="1200" dirty="0"/>
-          </a:p>
-        </p:txBody>
-      </p:sp>
-      <p:sp>
-        <p:nvSpPr>
-          <p:cNvPr id="12" name="Text 10"/>
-          <p:cNvSpPr txBox="1"/>
-          <p:nvPr/>
-        </p:nvSpPr>
-        <p:spPr>
-          <a:xfrm>
-            <a:off x="6350000" y="1778000"/>
-            <a:ext cx="2171700" cy="381000"/>
-          </a:xfrm>
-          <a:prstGeom prst="rect">
-            <a:avLst/>
-          </a:prstGeom>
-          <a:noFill/>
-          <a:ln/>
-        </p:spPr>
-        <p:txBody>
-          <a:bodyPr wrap="square" lIns="0" tIns="0" rIns="0" bIns="0" rtlCol="0" anchor="t"/>
-          <a:lstStyle/>
-          <a:p>
-            <a:pPr algn="l" indent="0" marL="0">
-              <a:buNone/>
-            </a:pPr>
-            <a:r>
-              <a:rPr lang="en-US" sz="2200" dirty="0">
-                <a:solidFill>
-                  <a:srgbClr val="EEF2F6"/>
-                </a:solidFill>
-                <a:latin typeface="Courier New" pitchFamily="34" charset="0"/>
-                <a:ea typeface="Courier New" pitchFamily="34" charset="-122"/>
-                <a:cs typeface="Courier New" pitchFamily="34" charset="-120"/>
-              </a:rPr>
-              <a:t>21 / 40</a:t>
-            </a:r>
-            <a:endParaRPr lang="en-US" sz="2200" dirty="0"/>
-          </a:p>
-        </p:txBody>
-      </p:sp>
-      <p:sp>
-        <p:nvSpPr>
-          <p:cNvPr id="13" name="Mandate stat"/>
-          <p:cNvSpPr/>
-          <p:nvPr/>
-        </p:nvSpPr>
-        <p:spPr>
-          <a:xfrm>
-            <a:off x="8851900" y="1333500"/>
-            <a:ext cx="2527300" cy="952500"/>
-          </a:xfrm>
-          <a:prstGeom prst="roundRect">
-            <a:avLst>
-              <a:gd name="adj" fmla="val 10667"/>
-            </a:avLst>
-          </a:prstGeom>
-          <a:solidFill>
-            <a:srgbClr val="0E1218"/>
-          </a:solidFill>
-          <a:ln w="9525">
-            <a:solidFill>
-              <a:srgbClr val="2F6B57"/>
-            </a:solidFill>
-            <a:prstDash val="solid"/>
-          </a:ln>
-        </p:spPr>
-      </p:sp>
-      <p:sp>
-        <p:nvSpPr>
-          <p:cNvPr id="14" name="Text 12"/>
-          <p:cNvSpPr txBox="1"/>
-          <p:nvPr/>
-        </p:nvSpPr>
-        <p:spPr>
-          <a:xfrm>
-            <a:off x="9029700" y="1498600"/>
-            <a:ext cx="2171700" cy="215900"/>
-          </a:xfrm>
-          <a:prstGeom prst="rect">
-            <a:avLst/>
-          </a:prstGeom>
-          <a:noFill/>
-          <a:ln/>
-        </p:spPr>
-        <p:txBody>
-          <a:bodyPr wrap="square" lIns="0" tIns="0" rIns="0" bIns="0" rtlCol="0" anchor="t"/>
-          <a:lstStyle/>
-          <a:p>
-            <a:pPr algn="l" indent="0" marL="0">
-              <a:buNone/>
-            </a:pPr>
-            <a:r>
-              <a:rPr lang="en-US" sz="1200" dirty="0">
-                <a:solidFill>
-                  <a:srgbClr val="8592A6"/>
-                </a:solidFill>
-              </a:rPr>
-              <a:t>Mandate</a:t>
-            </a:r>
-            <a:endParaRPr lang="en-US" sz="1200" dirty="0"/>
-          </a:p>
-        </p:txBody>
-      </p:sp>
-      <p:sp>
-        <p:nvSpPr>
-          <p:cNvPr id="15" name="Text 13"/>
-          <p:cNvSpPr txBox="1"/>
-          <p:nvPr/>
-        </p:nvSpPr>
-        <p:spPr>
-          <a:xfrm>
-            <a:off x="9029700" y="1778000"/>
-            <a:ext cx="2171700" cy="381000"/>
-          </a:xfrm>
-          <a:prstGeom prst="rect">
-            <a:avLst/>
-          </a:prstGeom>
-          <a:noFill/>
-          <a:ln/>
-        </p:spPr>
-        <p:txBody>
-          <a:bodyPr wrap="square" lIns="0" tIns="0" rIns="0" bIns="0" rtlCol="0" anchor="t"/>
-          <a:lstStyle/>
-          <a:p>
-            <a:pPr algn="l" indent="0" marL="0">
-              <a:buNone/>
-            </a:pPr>
-            <a:r>
-              <a:rPr lang="en-US" sz="2200" b="1" dirty="0">
-                <a:solidFill>
-                  <a:srgbClr val="7CF7C4"/>
-                </a:solidFill>
-              </a:rPr>
-              <a:t>✓ SAFE</a:t>
-            </a:r>
-            <a:endParaRPr lang="en-US" sz="2200" dirty="0"/>
-          </a:p>
-        </p:txBody>
-      </p:sp>
-      <p:sp>
-        <p:nvSpPr>
-          <p:cNvPr id="16" name="Allocation panel"/>
-          <p:cNvSpPr/>
-          <p:nvPr/>
-        </p:nvSpPr>
-        <p:spPr>
-          <a:xfrm>
-            <a:off x="812800" y="2476500"/>
-            <a:ext cx="6096000" cy="3302000"/>
-          </a:xfrm>
-          <a:prstGeom prst="roundRect">
-            <a:avLst>
-              <a:gd name="adj" fmla="val 3077"/>
-            </a:avLst>
-          </a:prstGeom>
-          <a:solidFill>
-            <a:srgbClr val="0E1218"/>
-          </a:solidFill>
-          <a:ln w="9525">
-            <a:solidFill>
-              <a:srgbClr val="1F2733"/>
-            </a:solidFill>
-            <a:prstDash val="solid"/>
-          </a:ln>
-        </p:spPr>
-      </p:sp>
-      <p:sp>
-        <p:nvSpPr>
-          <p:cNvPr id="17" name="Text 15"/>
-          <p:cNvSpPr txBox="1"/>
-          <p:nvPr/>
-        </p:nvSpPr>
-        <p:spPr>
-          <a:xfrm>
-            <a:off x="1016000" y="2654300"/>
-            <a:ext cx="2540000" cy="215900"/>
-          </a:xfrm>
-          <a:prstGeom prst="rect">
-            <a:avLst/>
-          </a:prstGeom>
-          <a:noFill/>
-          <a:ln/>
-        </p:spPr>
-        <p:txBody>
-          <a:bodyPr wrap="square" lIns="0" tIns="0" rIns="0" bIns="0" rtlCol="0" anchor="t"/>
-          <a:lstStyle/>
-          <a:p>
-            <a:pPr algn="l" indent="0" marL="0">
-              <a:buNone/>
-            </a:pPr>
-            <a:r>
-              <a:rPr lang="en-US" sz="1200" dirty="0">
-                <a:solidFill>
-                  <a:srgbClr val="8592A6"/>
-                </a:solidFill>
-              </a:rPr>
-              <a:t>Allocation</a:t>
-            </a:r>
-            <a:endParaRPr lang="en-US" sz="1200" dirty="0"/>
-          </a:p>
-        </p:txBody>
-      </p:sp>
-      <p:sp>
-        <p:nvSpPr>
-          <p:cNvPr id="18" name="Bar 1"/>
-          <p:cNvSpPr/>
-          <p:nvPr/>
-        </p:nvSpPr>
-        <p:spPr>
-          <a:xfrm>
-            <a:off x="1016000" y="2984500"/>
-            <a:ext cx="2275840" cy="152400"/>
-          </a:xfrm>
-          <a:prstGeom prst="rect">
-            <a:avLst/>
-          </a:prstGeom>
-          <a:solidFill>
-            <a:srgbClr val="5AA8FF"/>
-          </a:solidFill>
-          <a:ln/>
-        </p:spPr>
-      </p:sp>
-      <p:sp>
-        <p:nvSpPr>
-          <p:cNvPr id="19" name="Bar 2"/>
-          <p:cNvSpPr/>
-          <p:nvPr/>
-        </p:nvSpPr>
-        <p:spPr>
-          <a:xfrm>
-            <a:off x="3291840" y="2984500"/>
-            <a:ext cx="1991360" cy="152400"/>
-          </a:xfrm>
-          <a:prstGeom prst="rect">
+            <a:off x="812800" y="3022600"/>
+            <a:ext cx="114300" cy="114300"/>
+          </a:xfrm>
+          <a:prstGeom prst="ellipse">
             <a:avLst/>
           </a:prstGeom>
           <a:solidFill>
@@ -13091,1403 +12600,325 @@
       </p:sp>
       <p:sp>
         <p:nvSpPr>
-          <p:cNvPr id="20" name="Bar 3"/>
+          <p:cNvPr id="5" name="Point 1"/>
+          <p:cNvSpPr txBox="1"/>
+          <p:nvPr/>
+        </p:nvSpPr>
+        <p:spPr>
+          <a:xfrm>
+            <a:off x="1054100" y="2984500"/>
+            <a:ext cx="2552700" cy="254000"/>
+          </a:xfrm>
+          <a:prstGeom prst="rect">
+            <a:avLst/>
+          </a:prstGeom>
+          <a:noFill/>
+          <a:ln/>
+        </p:spPr>
+        <p:txBody>
+          <a:bodyPr wrap="square" lIns="0" tIns="0" rIns="0" bIns="0" rtlCol="0" anchor="t"/>
+          <a:lstStyle/>
+          <a:p>
+            <a:pPr algn="l" indent="0" marL="0">
+              <a:buNone/>
+            </a:pPr>
+            <a:r>
+              <a:rPr lang="en-US" sz="1500" b="1" dirty="0">
+                <a:solidFill>
+                  <a:srgbClr val="EEF2F6"/>
+                </a:solidFill>
+              </a:rPr>
+              <a:t>Live loop</a:t>
+            </a:r>
+            <a:endParaRPr lang="en-US" sz="1500" dirty="0"/>
+          </a:p>
+        </p:txBody>
+      </p:sp>
+      <p:sp>
+        <p:nvSpPr>
+          <p:cNvPr id="6" name="Point 1 detail"/>
+          <p:cNvSpPr txBox="1"/>
+          <p:nvPr/>
+        </p:nvSpPr>
+        <p:spPr>
+          <a:xfrm>
+            <a:off x="1054100" y="3263900"/>
+            <a:ext cx="2552700" cy="571500"/>
+          </a:xfrm>
+          <a:prstGeom prst="rect">
+            <a:avLst/>
+          </a:prstGeom>
+          <a:noFill/>
+          <a:ln/>
+        </p:spPr>
+        <p:txBody>
+          <a:bodyPr wrap="square" lIns="0" tIns="0" rIns="0" bIns="0" rtlCol="0" anchor="t"/>
+          <a:lstStyle/>
+          <a:p>
+            <a:pPr algn="l" indent="0" marL="0">
+              <a:lnSpc>
+                <a:spcPct val="125000"/>
+              </a:lnSpc>
+              <a:buNone/>
+            </a:pPr>
+            <a:r>
+              <a:rPr lang="en-US" sz="1200" dirty="0">
+                <a:solidFill>
+                  <a:srgbClr val="9AA8BA"/>
+                </a:solidFill>
+              </a:rPr>
+              <a:t>Each of the six steps streams in as it lands, with its transaction</a:t>
+            </a:r>
+            <a:endParaRPr lang="en-US" sz="1200" dirty="0"/>
+          </a:p>
+        </p:txBody>
+      </p:sp>
+      <p:sp>
+        <p:nvSpPr>
+          <p:cNvPr id="7" name="Point 2 dot"/>
           <p:cNvSpPr/>
           <p:nvPr/>
         </p:nvSpPr>
         <p:spPr>
           <a:xfrm>
-            <a:off x="5283200" y="2984500"/>
-            <a:ext cx="1422400" cy="152400"/>
+            <a:off x="812800" y="3975100"/>
+            <a:ext cx="114300" cy="114300"/>
+          </a:xfrm>
+          <a:prstGeom prst="ellipse">
+            <a:avLst/>
+          </a:prstGeom>
+          <a:solidFill>
+            <a:srgbClr val="7CF7C4"/>
+          </a:solidFill>
+          <a:ln/>
+        </p:spPr>
+      </p:sp>
+      <p:sp>
+        <p:nvSpPr>
+          <p:cNvPr id="8" name="Point 2"/>
+          <p:cNvSpPr txBox="1"/>
+          <p:nvPr/>
+        </p:nvSpPr>
+        <p:spPr>
+          <a:xfrm>
+            <a:off x="1054100" y="3937000"/>
+            <a:ext cx="2552700" cy="254000"/>
           </a:xfrm>
           <a:prstGeom prst="rect">
             <a:avLst/>
           </a:prstGeom>
+          <a:noFill/>
+          <a:ln/>
+        </p:spPr>
+        <p:txBody>
+          <a:bodyPr wrap="square" lIns="0" tIns="0" rIns="0" bIns="0" rtlCol="0" anchor="t"/>
+          <a:lstStyle/>
+          <a:p>
+            <a:pPr algn="l" indent="0" marL="0">
+              <a:buNone/>
+            </a:pPr>
+            <a:r>
+              <a:rPr lang="en-US" sz="1500" b="1" dirty="0">
+                <a:solidFill>
+                  <a:srgbClr val="EEF2F6"/>
+                </a:solidFill>
+              </a:rPr>
+              <a:t>Claude's decision</a:t>
+            </a:r>
+            <a:endParaRPr lang="en-US" sz="1500" dirty="0"/>
+          </a:p>
+        </p:txBody>
+      </p:sp>
+      <p:sp>
+        <p:nvSpPr>
+          <p:cNvPr id="9" name="Point 2 detail"/>
+          <p:cNvSpPr txBox="1"/>
+          <p:nvPr/>
+        </p:nvSpPr>
+        <p:spPr>
+          <a:xfrm>
+            <a:off x="1054100" y="4216400"/>
+            <a:ext cx="2552700" cy="571500"/>
+          </a:xfrm>
+          <a:prstGeom prst="rect">
+            <a:avLst/>
+          </a:prstGeom>
+          <a:noFill/>
+          <a:ln/>
+        </p:spPr>
+        <p:txBody>
+          <a:bodyPr wrap="square" lIns="0" tIns="0" rIns="0" bIns="0" rtlCol="0" anchor="t"/>
+          <a:lstStyle/>
+          <a:p>
+            <a:pPr algn="l" indent="0" marL="0">
+              <a:lnSpc>
+                <a:spcPct val="125000"/>
+              </a:lnSpc>
+              <a:buNone/>
+            </a:pPr>
+            <a:r>
+              <a:rPr lang="en-US" sz="1200" dirty="0">
+                <a:solidFill>
+                  <a:srgbClr val="9AA8BA"/>
+                </a:solidFill>
+              </a:rPr>
+              <a:t>Rationale, allocation and the policy check, side by side</a:t>
+            </a:r>
+            <a:endParaRPr lang="en-US" sz="1200" dirty="0"/>
+          </a:p>
+        </p:txBody>
+      </p:sp>
+      <p:sp>
+        <p:nvSpPr>
+          <p:cNvPr id="10" name="Point 3 dot"/>
+          <p:cNvSpPr/>
+          <p:nvPr/>
+        </p:nvSpPr>
+        <p:spPr>
+          <a:xfrm>
+            <a:off x="812800" y="4927600"/>
+            <a:ext cx="114300" cy="114300"/>
+          </a:xfrm>
+          <a:prstGeom prst="ellipse">
+            <a:avLst/>
+          </a:prstGeom>
           <a:solidFill>
-            <a:srgbClr val="3A4658"/>
+            <a:srgbClr val="7CF7C4"/>
           </a:solidFill>
           <a:ln/>
         </p:spPr>
       </p:sp>
-      <p:graphicFrame>
-        <p:nvGraphicFramePr>
-          <p:cNvPr id="10" name="Allocation table"/>
-          <p:cNvGraphicFramePr>
-            <a:graphicFrameLocks noGrp="1"/>
-          </p:cNvGraphicFramePr>
-          <p:nvPr>
-            <p:extLst>
-              <p:ext uri="{D42A27DB-BD31-4B8C-83A1-F6EECF244321}">
-                <p14:modId xmlns:p14="http://schemas.microsoft.com/office/powerpoint/2010/main" val="1579011935"/>
-              </p:ext>
-            </p:extLst>
-          </p:nvPr>
-        </p:nvGraphicFramePr>
-        <p:xfrm>
-          <a:off x="1016000" y="3365500"/>
-          <a:ext cx="5689600" cy="914400"/>
-        </p:xfrm>
-        <a:graphic>
-          <a:graphicData uri="http://schemas.openxmlformats.org/drawingml/2006/table">
-            <a:tbl>
-              <a:tblPr/>
-              <a:tblGrid>
-                <a:gridCol w="2768600"/>
-                <a:gridCol w="1016000"/>
-                <a:gridCol w="889000"/>
-                <a:gridCol w="1016000"/>
-              </a:tblGrid>
-              <a:tr h="419100">
-                <a:tc>
-                  <a:txBody>
-                    <a:bodyPr/>
-                    <a:lstStyle/>
-                    <a:p>
-                      <a:pPr algn="l" indent="0" marL="0">
-                        <a:buNone/>
-                      </a:pPr>
-                      <a:r>
-                        <a:rPr lang="en-US" sz="1200" dirty="0">
-                          <a:solidFill>
-                            <a:srgbClr val="8592A6"/>
-                          </a:solidFill>
-                          <a:latin typeface="Courier New" pitchFamily="34" charset="0"/>
-                          <a:ea typeface="Courier New" pitchFamily="34" charset="-122"/>
-                          <a:cs typeface="Courier New" pitchFamily="34" charset="-120"/>
-                        </a:rPr>
-                        <a:t>Strategy</a:t>
-                      </a:r>
-                      <a:endParaRPr lang="en-US" sz="1200" dirty="0">
-                        <a:latin typeface="Courier New" charset="0"/>
-                        <a:ea typeface="Courier New" charset="0"/>
-                        <a:cs typeface="Courier New" charset="0"/>
-                      </a:endParaRPr>
-                    </a:p>
-                  </a:txBody>
-                  <a:tcPr marL="63500" marR="63500" marT="0" marB="0" anchor="ctr">
-                    <a:lnL w="9525" cap="flat" cmpd="sng" algn="ctr">
-                      <a:solidFill>
-                        <a:srgbClr val="1F2733"/>
-                      </a:solidFill>
-                      <a:prstDash val="solid"/>
-                      <a:round/>
-                      <a:headEnd type="none" w="med" len="med"/>
-                      <a:tailEnd type="none" w="med" len="med"/>
-                    </a:lnL>
-                    <a:lnR w="9525" cap="flat" cmpd="sng" algn="ctr">
-                      <a:solidFill>
-                        <a:srgbClr val="1F2733"/>
-                      </a:solidFill>
-                      <a:prstDash val="solid"/>
-                      <a:round/>
-                      <a:headEnd type="none" w="med" len="med"/>
-                      <a:tailEnd type="none" w="med" len="med"/>
-                    </a:lnR>
-                    <a:lnT w="9525" cap="flat" cmpd="sng" algn="ctr">
-                      <a:solidFill>
-                        <a:srgbClr val="1F2733"/>
-                      </a:solidFill>
-                      <a:prstDash val="solid"/>
-                      <a:round/>
-                      <a:headEnd type="none" w="med" len="med"/>
-                      <a:tailEnd type="none" w="med" len="med"/>
-                    </a:lnT>
-                    <a:lnB w="9525" cap="flat" cmpd="sng" algn="ctr">
-                      <a:solidFill>
-                        <a:srgbClr val="1F2733"/>
-                      </a:solidFill>
-                      <a:prstDash val="solid"/>
-                      <a:round/>
-                      <a:headEnd type="none" w="med" len="med"/>
-                      <a:tailEnd type="none" w="med" len="med"/>
-                    </a:lnB>
-                  </a:tcPr>
-                </a:tc>
-                <a:tc>
-                  <a:txBody>
-                    <a:bodyPr/>
-                    <a:lstStyle/>
-                    <a:p>
-                      <a:pPr algn="r" indent="0" marL="0">
-                        <a:buNone/>
-                      </a:pPr>
-                      <a:r>
-                        <a:rPr lang="en-US" sz="1200" dirty="0">
-                          <a:solidFill>
-                            <a:srgbClr val="8592A6"/>
-                          </a:solidFill>
-                          <a:latin typeface="Courier New" pitchFamily="34" charset="0"/>
-                          <a:ea typeface="Courier New" pitchFamily="34" charset="-122"/>
-                          <a:cs typeface="Courier New" pitchFamily="34" charset="-120"/>
-                        </a:rPr>
-                        <a:t>APY</a:t>
-                      </a:r>
-                      <a:endParaRPr lang="en-US" sz="1200" dirty="0">
-                        <a:latin typeface="Courier New" charset="0"/>
-                        <a:ea typeface="Courier New" charset="0"/>
-                        <a:cs typeface="Courier New" charset="0"/>
-                      </a:endParaRPr>
-                    </a:p>
-                  </a:txBody>
-                  <a:tcPr marL="63500" marR="63500" marT="0" marB="0" anchor="ctr">
-                    <a:lnL w="9525" cap="flat" cmpd="sng" algn="ctr">
-                      <a:solidFill>
-                        <a:srgbClr val="1F2733"/>
-                      </a:solidFill>
-                      <a:prstDash val="solid"/>
-                      <a:round/>
-                      <a:headEnd type="none" w="med" len="med"/>
-                      <a:tailEnd type="none" w="med" len="med"/>
-                    </a:lnL>
-                    <a:lnR w="9525" cap="flat" cmpd="sng" algn="ctr">
-                      <a:solidFill>
-                        <a:srgbClr val="1F2733"/>
-                      </a:solidFill>
-                      <a:prstDash val="solid"/>
-                      <a:round/>
-                      <a:headEnd type="none" w="med" len="med"/>
-                      <a:tailEnd type="none" w="med" len="med"/>
-                    </a:lnR>
-                    <a:lnT w="9525" cap="flat" cmpd="sng" algn="ctr">
-                      <a:solidFill>
-                        <a:srgbClr val="1F2733"/>
-                      </a:solidFill>
-                      <a:prstDash val="solid"/>
-                      <a:round/>
-                      <a:headEnd type="none" w="med" len="med"/>
-                      <a:tailEnd type="none" w="med" len="med"/>
-                    </a:lnT>
-                    <a:lnB w="9525" cap="flat" cmpd="sng" algn="ctr">
-                      <a:solidFill>
-                        <a:srgbClr val="1F2733"/>
-                      </a:solidFill>
-                      <a:prstDash val="solid"/>
-                      <a:round/>
-                      <a:headEnd type="none" w="med" len="med"/>
-                      <a:tailEnd type="none" w="med" len="med"/>
-                    </a:lnB>
-                  </a:tcPr>
-                </a:tc>
-                <a:tc>
-                  <a:txBody>
-                    <a:bodyPr/>
-                    <a:lstStyle/>
-                    <a:p>
-                      <a:pPr algn="r" indent="0" marL="0">
-                        <a:buNone/>
-                      </a:pPr>
-                      <a:r>
-                        <a:rPr lang="en-US" sz="1200" dirty="0">
-                          <a:solidFill>
-                            <a:srgbClr val="8592A6"/>
-                          </a:solidFill>
-                          <a:latin typeface="Courier New" pitchFamily="34" charset="0"/>
-                          <a:ea typeface="Courier New" pitchFamily="34" charset="-122"/>
-                          <a:cs typeface="Courier New" pitchFamily="34" charset="-120"/>
-                        </a:rPr>
-                        <a:t>Risk</a:t>
-                      </a:r>
-                      <a:endParaRPr lang="en-US" sz="1200" dirty="0">
-                        <a:latin typeface="Courier New" charset="0"/>
-                        <a:ea typeface="Courier New" charset="0"/>
-                        <a:cs typeface="Courier New" charset="0"/>
-                      </a:endParaRPr>
-                    </a:p>
-                  </a:txBody>
-                  <a:tcPr marL="63500" marR="63500" marT="0" marB="0" anchor="ctr">
-                    <a:lnL w="9525" cap="flat" cmpd="sng" algn="ctr">
-                      <a:solidFill>
-                        <a:srgbClr val="1F2733"/>
-                      </a:solidFill>
-                      <a:prstDash val="solid"/>
-                      <a:round/>
-                      <a:headEnd type="none" w="med" len="med"/>
-                      <a:tailEnd type="none" w="med" len="med"/>
-                    </a:lnL>
-                    <a:lnR w="9525" cap="flat" cmpd="sng" algn="ctr">
-                      <a:solidFill>
-                        <a:srgbClr val="1F2733"/>
-                      </a:solidFill>
-                      <a:prstDash val="solid"/>
-                      <a:round/>
-                      <a:headEnd type="none" w="med" len="med"/>
-                      <a:tailEnd type="none" w="med" len="med"/>
-                    </a:lnR>
-                    <a:lnT w="9525" cap="flat" cmpd="sng" algn="ctr">
-                      <a:solidFill>
-                        <a:srgbClr val="1F2733"/>
-                      </a:solidFill>
-                      <a:prstDash val="solid"/>
-                      <a:round/>
-                      <a:headEnd type="none" w="med" len="med"/>
-                      <a:tailEnd type="none" w="med" len="med"/>
-                    </a:lnT>
-                    <a:lnB w="9525" cap="flat" cmpd="sng" algn="ctr">
-                      <a:solidFill>
-                        <a:srgbClr val="1F2733"/>
-                      </a:solidFill>
-                      <a:prstDash val="solid"/>
-                      <a:round/>
-                      <a:headEnd type="none" w="med" len="med"/>
-                      <a:tailEnd type="none" w="med" len="med"/>
-                    </a:lnB>
-                  </a:tcPr>
-                </a:tc>
-                <a:tc>
-                  <a:txBody>
-                    <a:bodyPr/>
-                    <a:lstStyle/>
-                    <a:p>
-                      <a:pPr algn="r" indent="0" marL="0">
-                        <a:buNone/>
-                      </a:pPr>
-                      <a:r>
-                        <a:rPr lang="en-US" sz="1200" dirty="0">
-                          <a:solidFill>
-                            <a:srgbClr val="8592A6"/>
-                          </a:solidFill>
-                          <a:latin typeface="Courier New" pitchFamily="34" charset="0"/>
-                          <a:ea typeface="Courier New" pitchFamily="34" charset="-122"/>
-                          <a:cs typeface="Courier New" pitchFamily="34" charset="-120"/>
-                        </a:rPr>
-                        <a:t>Weight</a:t>
-                      </a:r>
-                      <a:endParaRPr lang="en-US" sz="1200" dirty="0">
-                        <a:latin typeface="Courier New" charset="0"/>
-                        <a:ea typeface="Courier New" charset="0"/>
-                        <a:cs typeface="Courier New" charset="0"/>
-                      </a:endParaRPr>
-                    </a:p>
-                  </a:txBody>
-                  <a:tcPr marL="63500" marR="63500" marT="0" marB="0" anchor="ctr">
-                    <a:lnL w="9525" cap="flat" cmpd="sng" algn="ctr">
-                      <a:solidFill>
-                        <a:srgbClr val="1F2733"/>
-                      </a:solidFill>
-                      <a:prstDash val="solid"/>
-                      <a:round/>
-                      <a:headEnd type="none" w="med" len="med"/>
-                      <a:tailEnd type="none" w="med" len="med"/>
-                    </a:lnL>
-                    <a:lnR w="9525" cap="flat" cmpd="sng" algn="ctr">
-                      <a:solidFill>
-                        <a:srgbClr val="1F2733"/>
-                      </a:solidFill>
-                      <a:prstDash val="solid"/>
-                      <a:round/>
-                      <a:headEnd type="none" w="med" len="med"/>
-                      <a:tailEnd type="none" w="med" len="med"/>
-                    </a:lnR>
-                    <a:lnT w="9525" cap="flat" cmpd="sng" algn="ctr">
-                      <a:solidFill>
-                        <a:srgbClr val="1F2733"/>
-                      </a:solidFill>
-                      <a:prstDash val="solid"/>
-                      <a:round/>
-                      <a:headEnd type="none" w="med" len="med"/>
-                      <a:tailEnd type="none" w="med" len="med"/>
-                    </a:lnT>
-                    <a:lnB w="9525" cap="flat" cmpd="sng" algn="ctr">
-                      <a:solidFill>
-                        <a:srgbClr val="1F2733"/>
-                      </a:solidFill>
-                      <a:prstDash val="solid"/>
-                      <a:round/>
-                      <a:headEnd type="none" w="med" len="med"/>
-                      <a:tailEnd type="none" w="med" len="med"/>
-                    </a:lnB>
-                  </a:tcPr>
-                </a:tc>
-              </a:tr>
-              <a:tr h="419100">
-                <a:tc>
-                  <a:txBody>
-                    <a:bodyPr/>
-                    <a:lstStyle/>
-                    <a:p>
-                      <a:pPr algn="l" indent="0" marL="0">
-                        <a:buNone/>
-                      </a:pPr>
-                      <a:r>
-                        <a:rPr lang="en-US" sz="1200" dirty="0">
-                          <a:solidFill>
-                            <a:srgbClr val="EEF2F6"/>
-                          </a:solidFill>
-                          <a:latin typeface="Courier New" pitchFamily="34" charset="0"/>
-                          <a:ea typeface="Courier New" pitchFamily="34" charset="-122"/>
-                          <a:cs typeface="Courier New" pitchFamily="34" charset="-120"/>
-                        </a:rPr>
-                        <a:t>B · LP Yield</a:t>
-                      </a:r>
-                      <a:endParaRPr lang="en-US" sz="1200" dirty="0">
-                        <a:latin typeface="Courier New" charset="0"/>
-                        <a:ea typeface="Courier New" charset="0"/>
-                        <a:cs typeface="Courier New" charset="0"/>
-                      </a:endParaRPr>
-                    </a:p>
-                  </a:txBody>
-                  <a:tcPr marL="63500" marR="63500" marT="0" marB="0" anchor="ctr">
-                    <a:lnL w="9525" cap="flat" cmpd="sng" algn="ctr">
-                      <a:solidFill>
-                        <a:srgbClr val="1F2733"/>
-                      </a:solidFill>
-                      <a:prstDash val="solid"/>
-                      <a:round/>
-                      <a:headEnd type="none" w="med" len="med"/>
-                      <a:tailEnd type="none" w="med" len="med"/>
-                    </a:lnL>
-                    <a:lnR w="9525" cap="flat" cmpd="sng" algn="ctr">
-                      <a:solidFill>
-                        <a:srgbClr val="1F2733"/>
-                      </a:solidFill>
-                      <a:prstDash val="solid"/>
-                      <a:round/>
-                      <a:headEnd type="none" w="med" len="med"/>
-                      <a:tailEnd type="none" w="med" len="med"/>
-                    </a:lnR>
-                    <a:lnT w="9525" cap="flat" cmpd="sng" algn="ctr">
-                      <a:solidFill>
-                        <a:srgbClr val="1F2733"/>
-                      </a:solidFill>
-                      <a:prstDash val="solid"/>
-                      <a:round/>
-                      <a:headEnd type="none" w="med" len="med"/>
-                      <a:tailEnd type="none" w="med" len="med"/>
-                    </a:lnT>
-                    <a:lnB w="9525" cap="flat" cmpd="sng" algn="ctr">
-                      <a:solidFill>
-                        <a:srgbClr val="1F2733"/>
-                      </a:solidFill>
-                      <a:prstDash val="solid"/>
-                      <a:round/>
-                      <a:headEnd type="none" w="med" len="med"/>
-                      <a:tailEnd type="none" w="med" len="med"/>
-                    </a:lnB>
-                  </a:tcPr>
-                </a:tc>
-                <a:tc>
-                  <a:txBody>
-                    <a:bodyPr/>
-                    <a:lstStyle/>
-                    <a:p>
-                      <a:pPr algn="r" indent="0" marL="0">
-                        <a:buNone/>
-                      </a:pPr>
-                      <a:r>
-                        <a:rPr lang="en-US" sz="1200" dirty="0">
-                          <a:solidFill>
-                            <a:srgbClr val="EEF2F6"/>
-                          </a:solidFill>
-                          <a:latin typeface="Courier New" pitchFamily="34" charset="0"/>
-                          <a:ea typeface="Courier New" pitchFamily="34" charset="-122"/>
-                          <a:cs typeface="Courier New" pitchFamily="34" charset="-120"/>
-                        </a:rPr>
-                        <a:t>11.2%</a:t>
-                      </a:r>
-                      <a:endParaRPr lang="en-US" sz="1200" dirty="0">
-                        <a:latin typeface="Courier New" charset="0"/>
-                        <a:ea typeface="Courier New" charset="0"/>
-                        <a:cs typeface="Courier New" charset="0"/>
-                      </a:endParaRPr>
-                    </a:p>
-                  </a:txBody>
-                  <a:tcPr marL="63500" marR="63500" marT="0" marB="0" anchor="ctr">
-                    <a:lnL w="9525" cap="flat" cmpd="sng" algn="ctr">
-                      <a:solidFill>
-                        <a:srgbClr val="1F2733"/>
-                      </a:solidFill>
-                      <a:prstDash val="solid"/>
-                      <a:round/>
-                      <a:headEnd type="none" w="med" len="med"/>
-                      <a:tailEnd type="none" w="med" len="med"/>
-                    </a:lnL>
-                    <a:lnR w="9525" cap="flat" cmpd="sng" algn="ctr">
-                      <a:solidFill>
-                        <a:srgbClr val="1F2733"/>
-                      </a:solidFill>
-                      <a:prstDash val="solid"/>
-                      <a:round/>
-                      <a:headEnd type="none" w="med" len="med"/>
-                      <a:tailEnd type="none" w="med" len="med"/>
-                    </a:lnR>
-                    <a:lnT w="9525" cap="flat" cmpd="sng" algn="ctr">
-                      <a:solidFill>
-                        <a:srgbClr val="1F2733"/>
-                      </a:solidFill>
-                      <a:prstDash val="solid"/>
-                      <a:round/>
-                      <a:headEnd type="none" w="med" len="med"/>
-                      <a:tailEnd type="none" w="med" len="med"/>
-                    </a:lnT>
-                    <a:lnB w="9525" cap="flat" cmpd="sng" algn="ctr">
-                      <a:solidFill>
-                        <a:srgbClr val="1F2733"/>
-                      </a:solidFill>
-                      <a:prstDash val="solid"/>
-                      <a:round/>
-                      <a:headEnd type="none" w="med" len="med"/>
-                      <a:tailEnd type="none" w="med" len="med"/>
-                    </a:lnB>
-                  </a:tcPr>
-                </a:tc>
-                <a:tc>
-                  <a:txBody>
-                    <a:bodyPr/>
-                    <a:lstStyle/>
-                    <a:p>
-                      <a:pPr algn="r" indent="0" marL="0">
-                        <a:buNone/>
-                      </a:pPr>
-                      <a:r>
-                        <a:rPr lang="en-US" sz="1200" dirty="0">
-                          <a:solidFill>
-                            <a:srgbClr val="EEF2F6"/>
-                          </a:solidFill>
-                          <a:latin typeface="Courier New" pitchFamily="34" charset="0"/>
-                          <a:ea typeface="Courier New" pitchFamily="34" charset="-122"/>
-                          <a:cs typeface="Courier New" pitchFamily="34" charset="-120"/>
-                        </a:rPr>
-                        <a:t>34</a:t>
-                      </a:r>
-                      <a:endParaRPr lang="en-US" sz="1200" dirty="0">
-                        <a:latin typeface="Courier New" charset="0"/>
-                        <a:ea typeface="Courier New" charset="0"/>
-                        <a:cs typeface="Courier New" charset="0"/>
-                      </a:endParaRPr>
-                    </a:p>
-                  </a:txBody>
-                  <a:tcPr marL="63500" marR="63500" marT="0" marB="0" anchor="ctr">
-                    <a:lnL w="9525" cap="flat" cmpd="sng" algn="ctr">
-                      <a:solidFill>
-                        <a:srgbClr val="1F2733"/>
-                      </a:solidFill>
-                      <a:prstDash val="solid"/>
-                      <a:round/>
-                      <a:headEnd type="none" w="med" len="med"/>
-                      <a:tailEnd type="none" w="med" len="med"/>
-                    </a:lnL>
-                    <a:lnR w="9525" cap="flat" cmpd="sng" algn="ctr">
-                      <a:solidFill>
-                        <a:srgbClr val="1F2733"/>
-                      </a:solidFill>
-                      <a:prstDash val="solid"/>
-                      <a:round/>
-                      <a:headEnd type="none" w="med" len="med"/>
-                      <a:tailEnd type="none" w="med" len="med"/>
-                    </a:lnR>
-                    <a:lnT w="9525" cap="flat" cmpd="sng" algn="ctr">
-                      <a:solidFill>
-                        <a:srgbClr val="1F2733"/>
-                      </a:solidFill>
-                      <a:prstDash val="solid"/>
-                      <a:round/>
-                      <a:headEnd type="none" w="med" len="med"/>
-                      <a:tailEnd type="none" w="med" len="med"/>
-                    </a:lnT>
-                    <a:lnB w="9525" cap="flat" cmpd="sng" algn="ctr">
-                      <a:solidFill>
-                        <a:srgbClr val="1F2733"/>
-                      </a:solidFill>
-                      <a:prstDash val="solid"/>
-                      <a:round/>
-                      <a:headEnd type="none" w="med" len="med"/>
-                      <a:tailEnd type="none" w="med" len="med"/>
-                    </a:lnB>
-                  </a:tcPr>
-                </a:tc>
-                <a:tc>
-                  <a:txBody>
-                    <a:bodyPr/>
-                    <a:lstStyle/>
-                    <a:p>
-                      <a:pPr algn="r" indent="0" marL="0">
-                        <a:buNone/>
-                      </a:pPr>
-                      <a:r>
-                        <a:rPr lang="en-US" sz="1200" dirty="0">
-                          <a:solidFill>
-                            <a:srgbClr val="EEF2F6"/>
-                          </a:solidFill>
-                          <a:latin typeface="Courier New" pitchFamily="34" charset="0"/>
-                          <a:ea typeface="Courier New" pitchFamily="34" charset="-122"/>
-                          <a:cs typeface="Courier New" pitchFamily="34" charset="-120"/>
-                        </a:rPr>
-                        <a:t>40%</a:t>
-                      </a:r>
-                      <a:endParaRPr lang="en-US" sz="1200" dirty="0">
-                        <a:latin typeface="Courier New" charset="0"/>
-                        <a:ea typeface="Courier New" charset="0"/>
-                        <a:cs typeface="Courier New" charset="0"/>
-                      </a:endParaRPr>
-                    </a:p>
-                  </a:txBody>
-                  <a:tcPr marL="63500" marR="63500" marT="0" marB="0" anchor="ctr">
-                    <a:lnL w="9525" cap="flat" cmpd="sng" algn="ctr">
-                      <a:solidFill>
-                        <a:srgbClr val="1F2733"/>
-                      </a:solidFill>
-                      <a:prstDash val="solid"/>
-                      <a:round/>
-                      <a:headEnd type="none" w="med" len="med"/>
-                      <a:tailEnd type="none" w="med" len="med"/>
-                    </a:lnL>
-                    <a:lnR w="9525" cap="flat" cmpd="sng" algn="ctr">
-                      <a:solidFill>
-                        <a:srgbClr val="1F2733"/>
-                      </a:solidFill>
-                      <a:prstDash val="solid"/>
-                      <a:round/>
-                      <a:headEnd type="none" w="med" len="med"/>
-                      <a:tailEnd type="none" w="med" len="med"/>
-                    </a:lnR>
-                    <a:lnT w="9525" cap="flat" cmpd="sng" algn="ctr">
-                      <a:solidFill>
-                        <a:srgbClr val="1F2733"/>
-                      </a:solidFill>
-                      <a:prstDash val="solid"/>
-                      <a:round/>
-                      <a:headEnd type="none" w="med" len="med"/>
-                      <a:tailEnd type="none" w="med" len="med"/>
-                    </a:lnT>
-                    <a:lnB w="9525" cap="flat" cmpd="sng" algn="ctr">
-                      <a:solidFill>
-                        <a:srgbClr val="1F2733"/>
-                      </a:solidFill>
-                      <a:prstDash val="solid"/>
-                      <a:round/>
-                      <a:headEnd type="none" w="med" len="med"/>
-                      <a:tailEnd type="none" w="med" len="med"/>
-                    </a:lnB>
-                  </a:tcPr>
-                </a:tc>
-              </a:tr>
-              <a:tr h="419100">
-                <a:tc>
-                  <a:txBody>
-                    <a:bodyPr/>
-                    <a:lstStyle/>
-                    <a:p>
-                      <a:pPr algn="l" indent="0" marL="0">
-                        <a:buNone/>
-                      </a:pPr>
-                      <a:r>
-                        <a:rPr lang="en-US" sz="1200" dirty="0">
-                          <a:solidFill>
-                            <a:srgbClr val="EEF2F6"/>
-                          </a:solidFill>
-                          <a:latin typeface="Courier New" pitchFamily="34" charset="0"/>
-                          <a:ea typeface="Courier New" pitchFamily="34" charset="-122"/>
-                          <a:cs typeface="Courier New" pitchFamily="34" charset="-120"/>
-                        </a:rPr>
-                        <a:t>A · Stable Lending</a:t>
-                      </a:r>
-                      <a:endParaRPr lang="en-US" sz="1200" dirty="0">
-                        <a:latin typeface="Courier New" charset="0"/>
-                        <a:ea typeface="Courier New" charset="0"/>
-                        <a:cs typeface="Courier New" charset="0"/>
-                      </a:endParaRPr>
-                    </a:p>
-                  </a:txBody>
-                  <a:tcPr marL="63500" marR="63500" marT="0" marB="0" anchor="ctr">
-                    <a:lnL w="9525" cap="flat" cmpd="sng" algn="ctr">
-                      <a:solidFill>
-                        <a:srgbClr val="1F2733"/>
-                      </a:solidFill>
-                      <a:prstDash val="solid"/>
-                      <a:round/>
-                      <a:headEnd type="none" w="med" len="med"/>
-                      <a:tailEnd type="none" w="med" len="med"/>
-                    </a:lnL>
-                    <a:lnR w="9525" cap="flat" cmpd="sng" algn="ctr">
-                      <a:solidFill>
-                        <a:srgbClr val="1F2733"/>
-                      </a:solidFill>
-                      <a:prstDash val="solid"/>
-                      <a:round/>
-                      <a:headEnd type="none" w="med" len="med"/>
-                      <a:tailEnd type="none" w="med" len="med"/>
-                    </a:lnR>
-                    <a:lnT w="9525" cap="flat" cmpd="sng" algn="ctr">
-                      <a:solidFill>
-                        <a:srgbClr val="1F2733"/>
-                      </a:solidFill>
-                      <a:prstDash val="solid"/>
-                      <a:round/>
-                      <a:headEnd type="none" w="med" len="med"/>
-                      <a:tailEnd type="none" w="med" len="med"/>
-                    </a:lnT>
-                    <a:lnB w="9525" cap="flat" cmpd="sng" algn="ctr">
-                      <a:solidFill>
-                        <a:srgbClr val="1F2733"/>
-                      </a:solidFill>
-                      <a:prstDash val="solid"/>
-                      <a:round/>
-                      <a:headEnd type="none" w="med" len="med"/>
-                      <a:tailEnd type="none" w="med" len="med"/>
-                    </a:lnB>
-                  </a:tcPr>
-                </a:tc>
-                <a:tc>
-                  <a:txBody>
-                    <a:bodyPr/>
-                    <a:lstStyle/>
-                    <a:p>
-                      <a:pPr algn="r" indent="0" marL="0">
-                        <a:buNone/>
-                      </a:pPr>
-                      <a:r>
-                        <a:rPr lang="en-US" sz="1200" dirty="0">
-                          <a:solidFill>
-                            <a:srgbClr val="EEF2F6"/>
-                          </a:solidFill>
-                          <a:latin typeface="Courier New" pitchFamily="34" charset="0"/>
-                          <a:ea typeface="Courier New" pitchFamily="34" charset="-122"/>
-                          <a:cs typeface="Courier New" pitchFamily="34" charset="-120"/>
-                        </a:rPr>
-                        <a:t>8.4%</a:t>
-                      </a:r>
-                      <a:endParaRPr lang="en-US" sz="1200" dirty="0">
-                        <a:latin typeface="Courier New" charset="0"/>
-                        <a:ea typeface="Courier New" charset="0"/>
-                        <a:cs typeface="Courier New" charset="0"/>
-                      </a:endParaRPr>
-                    </a:p>
-                  </a:txBody>
-                  <a:tcPr marL="63500" marR="63500" marT="0" marB="0" anchor="ctr">
-                    <a:lnL w="9525" cap="flat" cmpd="sng" algn="ctr">
-                      <a:solidFill>
-                        <a:srgbClr val="1F2733"/>
-                      </a:solidFill>
-                      <a:prstDash val="solid"/>
-                      <a:round/>
-                      <a:headEnd type="none" w="med" len="med"/>
-                      <a:tailEnd type="none" w="med" len="med"/>
-                    </a:lnL>
-                    <a:lnR w="9525" cap="flat" cmpd="sng" algn="ctr">
-                      <a:solidFill>
-                        <a:srgbClr val="1F2733"/>
-                      </a:solidFill>
-                      <a:prstDash val="solid"/>
-                      <a:round/>
-                      <a:headEnd type="none" w="med" len="med"/>
-                      <a:tailEnd type="none" w="med" len="med"/>
-                    </a:lnR>
-                    <a:lnT w="9525" cap="flat" cmpd="sng" algn="ctr">
-                      <a:solidFill>
-                        <a:srgbClr val="1F2733"/>
-                      </a:solidFill>
-                      <a:prstDash val="solid"/>
-                      <a:round/>
-                      <a:headEnd type="none" w="med" len="med"/>
-                      <a:tailEnd type="none" w="med" len="med"/>
-                    </a:lnT>
-                    <a:lnB w="9525" cap="flat" cmpd="sng" algn="ctr">
-                      <a:solidFill>
-                        <a:srgbClr val="1F2733"/>
-                      </a:solidFill>
-                      <a:prstDash val="solid"/>
-                      <a:round/>
-                      <a:headEnd type="none" w="med" len="med"/>
-                      <a:tailEnd type="none" w="med" len="med"/>
-                    </a:lnB>
-                  </a:tcPr>
-                </a:tc>
-                <a:tc>
-                  <a:txBody>
-                    <a:bodyPr/>
-                    <a:lstStyle/>
-                    <a:p>
-                      <a:pPr algn="r" indent="0" marL="0">
-                        <a:buNone/>
-                      </a:pPr>
-                      <a:r>
-                        <a:rPr lang="en-US" sz="1200" dirty="0">
-                          <a:solidFill>
-                            <a:srgbClr val="EEF2F6"/>
-                          </a:solidFill>
-                          <a:latin typeface="Courier New" pitchFamily="34" charset="0"/>
-                          <a:ea typeface="Courier New" pitchFamily="34" charset="-122"/>
-                          <a:cs typeface="Courier New" pitchFamily="34" charset="-120"/>
-                        </a:rPr>
-                        <a:t>21</a:t>
-                      </a:r>
-                      <a:endParaRPr lang="en-US" sz="1200" dirty="0">
-                        <a:latin typeface="Courier New" charset="0"/>
-                        <a:ea typeface="Courier New" charset="0"/>
-                        <a:cs typeface="Courier New" charset="0"/>
-                      </a:endParaRPr>
-                    </a:p>
-                  </a:txBody>
-                  <a:tcPr marL="63500" marR="63500" marT="0" marB="0" anchor="ctr">
-                    <a:lnL w="9525" cap="flat" cmpd="sng" algn="ctr">
-                      <a:solidFill>
-                        <a:srgbClr val="1F2733"/>
-                      </a:solidFill>
-                      <a:prstDash val="solid"/>
-                      <a:round/>
-                      <a:headEnd type="none" w="med" len="med"/>
-                      <a:tailEnd type="none" w="med" len="med"/>
-                    </a:lnL>
-                    <a:lnR w="9525" cap="flat" cmpd="sng" algn="ctr">
-                      <a:solidFill>
-                        <a:srgbClr val="1F2733"/>
-                      </a:solidFill>
-                      <a:prstDash val="solid"/>
-                      <a:round/>
-                      <a:headEnd type="none" w="med" len="med"/>
-                      <a:tailEnd type="none" w="med" len="med"/>
-                    </a:lnR>
-                    <a:lnT w="9525" cap="flat" cmpd="sng" algn="ctr">
-                      <a:solidFill>
-                        <a:srgbClr val="1F2733"/>
-                      </a:solidFill>
-                      <a:prstDash val="solid"/>
-                      <a:round/>
-                      <a:headEnd type="none" w="med" len="med"/>
-                      <a:tailEnd type="none" w="med" len="med"/>
-                    </a:lnT>
-                    <a:lnB w="9525" cap="flat" cmpd="sng" algn="ctr">
-                      <a:solidFill>
-                        <a:srgbClr val="1F2733"/>
-                      </a:solidFill>
-                      <a:prstDash val="solid"/>
-                      <a:round/>
-                      <a:headEnd type="none" w="med" len="med"/>
-                      <a:tailEnd type="none" w="med" len="med"/>
-                    </a:lnB>
-                  </a:tcPr>
-                </a:tc>
-                <a:tc>
-                  <a:txBody>
-                    <a:bodyPr/>
-                    <a:lstStyle/>
-                    <a:p>
-                      <a:pPr algn="r" indent="0" marL="0">
-                        <a:buNone/>
-                      </a:pPr>
-                      <a:r>
-                        <a:rPr lang="en-US" sz="1200" dirty="0">
-                          <a:solidFill>
-                            <a:srgbClr val="EEF2F6"/>
-                          </a:solidFill>
-                          <a:latin typeface="Courier New" pitchFamily="34" charset="0"/>
-                          <a:ea typeface="Courier New" pitchFamily="34" charset="-122"/>
-                          <a:cs typeface="Courier New" pitchFamily="34" charset="-120"/>
-                        </a:rPr>
-                        <a:t>35%</a:t>
-                      </a:r>
-                      <a:endParaRPr lang="en-US" sz="1200" dirty="0">
-                        <a:latin typeface="Courier New" charset="0"/>
-                        <a:ea typeface="Courier New" charset="0"/>
-                        <a:cs typeface="Courier New" charset="0"/>
-                      </a:endParaRPr>
-                    </a:p>
-                  </a:txBody>
-                  <a:tcPr marL="63500" marR="63500" marT="0" marB="0" anchor="ctr">
-                    <a:lnL w="9525" cap="flat" cmpd="sng" algn="ctr">
-                      <a:solidFill>
-                        <a:srgbClr val="1F2733"/>
-                      </a:solidFill>
-                      <a:prstDash val="solid"/>
-                      <a:round/>
-                      <a:headEnd type="none" w="med" len="med"/>
-                      <a:tailEnd type="none" w="med" len="med"/>
-                    </a:lnL>
-                    <a:lnR w="9525" cap="flat" cmpd="sng" algn="ctr">
-                      <a:solidFill>
-                        <a:srgbClr val="1F2733"/>
-                      </a:solidFill>
-                      <a:prstDash val="solid"/>
-                      <a:round/>
-                      <a:headEnd type="none" w="med" len="med"/>
-                      <a:tailEnd type="none" w="med" len="med"/>
-                    </a:lnR>
-                    <a:lnT w="9525" cap="flat" cmpd="sng" algn="ctr">
-                      <a:solidFill>
-                        <a:srgbClr val="1F2733"/>
-                      </a:solidFill>
-                      <a:prstDash val="solid"/>
-                      <a:round/>
-                      <a:headEnd type="none" w="med" len="med"/>
-                      <a:tailEnd type="none" w="med" len="med"/>
-                    </a:lnT>
-                    <a:lnB w="9525" cap="flat" cmpd="sng" algn="ctr">
-                      <a:solidFill>
-                        <a:srgbClr val="1F2733"/>
-                      </a:solidFill>
-                      <a:prstDash val="solid"/>
-                      <a:round/>
-                      <a:headEnd type="none" w="med" len="med"/>
-                      <a:tailEnd type="none" w="med" len="med"/>
-                    </a:lnB>
-                  </a:tcPr>
-                </a:tc>
-              </a:tr>
-              <a:tr h="419100">
-                <a:tc>
-                  <a:txBody>
-                    <a:bodyPr/>
-                    <a:lstStyle/>
-                    <a:p>
-                      <a:pPr algn="l" indent="0" marL="0">
-                        <a:buNone/>
-                      </a:pPr>
-                      <a:r>
-                        <a:rPr lang="en-US" sz="1200" dirty="0">
-                          <a:solidFill>
-                            <a:srgbClr val="EEF2F6"/>
-                          </a:solidFill>
-                          <a:latin typeface="Courier New" pitchFamily="34" charset="0"/>
-                          <a:ea typeface="Courier New" pitchFamily="34" charset="-122"/>
-                          <a:cs typeface="Courier New" pitchFamily="34" charset="-120"/>
-                        </a:rPr>
-                        <a:t>C · T-Bill Vault</a:t>
-                      </a:r>
-                      <a:endParaRPr lang="en-US" sz="1200" dirty="0">
-                        <a:latin typeface="Courier New" charset="0"/>
-                        <a:ea typeface="Courier New" charset="0"/>
-                        <a:cs typeface="Courier New" charset="0"/>
-                      </a:endParaRPr>
-                    </a:p>
-                  </a:txBody>
-                  <a:tcPr marL="63500" marR="63500" marT="0" marB="0" anchor="ctr">
-                    <a:lnL w="9525" cap="flat" cmpd="sng" algn="ctr">
-                      <a:solidFill>
-                        <a:srgbClr val="1F2733"/>
-                      </a:solidFill>
-                      <a:prstDash val="solid"/>
-                      <a:round/>
-                      <a:headEnd type="none" w="med" len="med"/>
-                      <a:tailEnd type="none" w="med" len="med"/>
-                    </a:lnL>
-                    <a:lnR w="9525" cap="flat" cmpd="sng" algn="ctr">
-                      <a:solidFill>
-                        <a:srgbClr val="1F2733"/>
-                      </a:solidFill>
-                      <a:prstDash val="solid"/>
-                      <a:round/>
-                      <a:headEnd type="none" w="med" len="med"/>
-                      <a:tailEnd type="none" w="med" len="med"/>
-                    </a:lnR>
-                    <a:lnT w="9525" cap="flat" cmpd="sng" algn="ctr">
-                      <a:solidFill>
-                        <a:srgbClr val="1F2733"/>
-                      </a:solidFill>
-                      <a:prstDash val="solid"/>
-                      <a:round/>
-                      <a:headEnd type="none" w="med" len="med"/>
-                      <a:tailEnd type="none" w="med" len="med"/>
-                    </a:lnT>
-                    <a:lnB w="9525" cap="flat" cmpd="sng" algn="ctr">
-                      <a:solidFill>
-                        <a:srgbClr val="1F2733"/>
-                      </a:solidFill>
-                      <a:prstDash val="solid"/>
-                      <a:round/>
-                      <a:headEnd type="none" w="med" len="med"/>
-                      <a:tailEnd type="none" w="med" len="med"/>
-                    </a:lnB>
-                  </a:tcPr>
-                </a:tc>
-                <a:tc>
-                  <a:txBody>
-                    <a:bodyPr/>
-                    <a:lstStyle/>
-                    <a:p>
-                      <a:pPr algn="r" indent="0" marL="0">
-                        <a:buNone/>
-                      </a:pPr>
-                      <a:r>
-                        <a:rPr lang="en-US" sz="1200" dirty="0">
-                          <a:solidFill>
-                            <a:srgbClr val="EEF2F6"/>
-                          </a:solidFill>
-                          <a:latin typeface="Courier New" pitchFamily="34" charset="0"/>
-                          <a:ea typeface="Courier New" pitchFamily="34" charset="-122"/>
-                          <a:cs typeface="Courier New" pitchFamily="34" charset="-120"/>
-                        </a:rPr>
-                        <a:t>6.8%</a:t>
-                      </a:r>
-                      <a:endParaRPr lang="en-US" sz="1200" dirty="0">
-                        <a:latin typeface="Courier New" charset="0"/>
-                        <a:ea typeface="Courier New" charset="0"/>
-                        <a:cs typeface="Courier New" charset="0"/>
-                      </a:endParaRPr>
-                    </a:p>
-                  </a:txBody>
-                  <a:tcPr marL="63500" marR="63500" marT="0" marB="0" anchor="ctr">
-                    <a:lnL w="9525" cap="flat" cmpd="sng" algn="ctr">
-                      <a:solidFill>
-                        <a:srgbClr val="1F2733"/>
-                      </a:solidFill>
-                      <a:prstDash val="solid"/>
-                      <a:round/>
-                      <a:headEnd type="none" w="med" len="med"/>
-                      <a:tailEnd type="none" w="med" len="med"/>
-                    </a:lnL>
-                    <a:lnR w="9525" cap="flat" cmpd="sng" algn="ctr">
-                      <a:solidFill>
-                        <a:srgbClr val="1F2733"/>
-                      </a:solidFill>
-                      <a:prstDash val="solid"/>
-                      <a:round/>
-                      <a:headEnd type="none" w="med" len="med"/>
-                      <a:tailEnd type="none" w="med" len="med"/>
-                    </a:lnR>
-                    <a:lnT w="9525" cap="flat" cmpd="sng" algn="ctr">
-                      <a:solidFill>
-                        <a:srgbClr val="1F2733"/>
-                      </a:solidFill>
-                      <a:prstDash val="solid"/>
-                      <a:round/>
-                      <a:headEnd type="none" w="med" len="med"/>
-                      <a:tailEnd type="none" w="med" len="med"/>
-                    </a:lnT>
-                    <a:lnB w="9525" cap="flat" cmpd="sng" algn="ctr">
-                      <a:solidFill>
-                        <a:srgbClr val="1F2733"/>
-                      </a:solidFill>
-                      <a:prstDash val="solid"/>
-                      <a:round/>
-                      <a:headEnd type="none" w="med" len="med"/>
-                      <a:tailEnd type="none" w="med" len="med"/>
-                    </a:lnB>
-                  </a:tcPr>
-                </a:tc>
-                <a:tc>
-                  <a:txBody>
-                    <a:bodyPr/>
-                    <a:lstStyle/>
-                    <a:p>
-                      <a:pPr algn="r" indent="0" marL="0">
-                        <a:buNone/>
-                      </a:pPr>
-                      <a:r>
-                        <a:rPr lang="en-US" sz="1200" dirty="0">
-                          <a:solidFill>
-                            <a:srgbClr val="EEF2F6"/>
-                          </a:solidFill>
-                          <a:latin typeface="Courier New" pitchFamily="34" charset="0"/>
-                          <a:ea typeface="Courier New" pitchFamily="34" charset="-122"/>
-                          <a:cs typeface="Courier New" pitchFamily="34" charset="-120"/>
-                        </a:rPr>
-                        <a:t>15</a:t>
-                      </a:r>
-                      <a:endParaRPr lang="en-US" sz="1200" dirty="0">
-                        <a:latin typeface="Courier New" charset="0"/>
-                        <a:ea typeface="Courier New" charset="0"/>
-                        <a:cs typeface="Courier New" charset="0"/>
-                      </a:endParaRPr>
-                    </a:p>
-                  </a:txBody>
-                  <a:tcPr marL="63500" marR="63500" marT="0" marB="0" anchor="ctr">
-                    <a:lnL w="9525" cap="flat" cmpd="sng" algn="ctr">
-                      <a:solidFill>
-                        <a:srgbClr val="1F2733"/>
-                      </a:solidFill>
-                      <a:prstDash val="solid"/>
-                      <a:round/>
-                      <a:headEnd type="none" w="med" len="med"/>
-                      <a:tailEnd type="none" w="med" len="med"/>
-                    </a:lnL>
-                    <a:lnR w="9525" cap="flat" cmpd="sng" algn="ctr">
-                      <a:solidFill>
-                        <a:srgbClr val="1F2733"/>
-                      </a:solidFill>
-                      <a:prstDash val="solid"/>
-                      <a:round/>
-                      <a:headEnd type="none" w="med" len="med"/>
-                      <a:tailEnd type="none" w="med" len="med"/>
-                    </a:lnR>
-                    <a:lnT w="9525" cap="flat" cmpd="sng" algn="ctr">
-                      <a:solidFill>
-                        <a:srgbClr val="1F2733"/>
-                      </a:solidFill>
-                      <a:prstDash val="solid"/>
-                      <a:round/>
-                      <a:headEnd type="none" w="med" len="med"/>
-                      <a:tailEnd type="none" w="med" len="med"/>
-                    </a:lnT>
-                    <a:lnB w="9525" cap="flat" cmpd="sng" algn="ctr">
-                      <a:solidFill>
-                        <a:srgbClr val="1F2733"/>
-                      </a:solidFill>
-                      <a:prstDash val="solid"/>
-                      <a:round/>
-                      <a:headEnd type="none" w="med" len="med"/>
-                      <a:tailEnd type="none" w="med" len="med"/>
-                    </a:lnB>
-                  </a:tcPr>
-                </a:tc>
-                <a:tc>
-                  <a:txBody>
-                    <a:bodyPr/>
-                    <a:lstStyle/>
-                    <a:p>
-                      <a:pPr algn="r" indent="0" marL="0">
-                        <a:buNone/>
-                      </a:pPr>
-                      <a:r>
-                        <a:rPr lang="en-US" sz="1200" dirty="0">
-                          <a:solidFill>
-                            <a:srgbClr val="EEF2F6"/>
-                          </a:solidFill>
-                          <a:latin typeface="Courier New" pitchFamily="34" charset="0"/>
-                          <a:ea typeface="Courier New" pitchFamily="34" charset="-122"/>
-                          <a:cs typeface="Courier New" pitchFamily="34" charset="-120"/>
-                        </a:rPr>
-                        <a:t>0%</a:t>
-                      </a:r>
-                      <a:endParaRPr lang="en-US" sz="1200" dirty="0">
-                        <a:latin typeface="Courier New" charset="0"/>
-                        <a:ea typeface="Courier New" charset="0"/>
-                        <a:cs typeface="Courier New" charset="0"/>
-                      </a:endParaRPr>
-                    </a:p>
-                  </a:txBody>
-                  <a:tcPr marL="63500" marR="63500" marT="0" marB="0" anchor="ctr">
-                    <a:lnL w="9525" cap="flat" cmpd="sng" algn="ctr">
-                      <a:solidFill>
-                        <a:srgbClr val="1F2733"/>
-                      </a:solidFill>
-                      <a:prstDash val="solid"/>
-                      <a:round/>
-                      <a:headEnd type="none" w="med" len="med"/>
-                      <a:tailEnd type="none" w="med" len="med"/>
-                    </a:lnL>
-                    <a:lnR w="9525" cap="flat" cmpd="sng" algn="ctr">
-                      <a:solidFill>
-                        <a:srgbClr val="1F2733"/>
-                      </a:solidFill>
-                      <a:prstDash val="solid"/>
-                      <a:round/>
-                      <a:headEnd type="none" w="med" len="med"/>
-                      <a:tailEnd type="none" w="med" len="med"/>
-                    </a:lnR>
-                    <a:lnT w="9525" cap="flat" cmpd="sng" algn="ctr">
-                      <a:solidFill>
-                        <a:srgbClr val="1F2733"/>
-                      </a:solidFill>
-                      <a:prstDash val="solid"/>
-                      <a:round/>
-                      <a:headEnd type="none" w="med" len="med"/>
-                      <a:tailEnd type="none" w="med" len="med"/>
-                    </a:lnT>
-                    <a:lnB w="9525" cap="flat" cmpd="sng" algn="ctr">
-                      <a:solidFill>
-                        <a:srgbClr val="1F2733"/>
-                      </a:solidFill>
-                      <a:prstDash val="solid"/>
-                      <a:round/>
-                      <a:headEnd type="none" w="med" len="med"/>
-                      <a:tailEnd type="none" w="med" len="med"/>
-                    </a:lnB>
-                  </a:tcPr>
-                </a:tc>
-              </a:tr>
-              <a:tr h="419100">
-                <a:tc>
-                  <a:txBody>
-                    <a:bodyPr/>
-                    <a:lstStyle/>
-                    <a:p>
-                      <a:pPr algn="l" indent="0" marL="0">
-                        <a:buNone/>
-                      </a:pPr>
-                      <a:r>
-                        <a:rPr lang="en-US" sz="1200" dirty="0">
-                          <a:solidFill>
-                            <a:srgbClr val="EEF2F6"/>
-                          </a:solidFill>
-                          <a:latin typeface="Courier New" pitchFamily="34" charset="0"/>
-                          <a:ea typeface="Courier New" pitchFamily="34" charset="-122"/>
-                          <a:cs typeface="Courier New" pitchFamily="34" charset="-120"/>
-                        </a:rPr>
-                        <a:t>USDC Reserve</a:t>
-                      </a:r>
-                      <a:endParaRPr lang="en-US" sz="1200" dirty="0">
-                        <a:latin typeface="Courier New" charset="0"/>
-                        <a:ea typeface="Courier New" charset="0"/>
-                        <a:cs typeface="Courier New" charset="0"/>
-                      </a:endParaRPr>
-                    </a:p>
-                  </a:txBody>
-                  <a:tcPr marL="63500" marR="63500" marT="0" marB="0" anchor="ctr">
-                    <a:lnL w="9525" cap="flat" cmpd="sng" algn="ctr">
-                      <a:solidFill>
-                        <a:srgbClr val="1F2733"/>
-                      </a:solidFill>
-                      <a:prstDash val="solid"/>
-                      <a:round/>
-                      <a:headEnd type="none" w="med" len="med"/>
-                      <a:tailEnd type="none" w="med" len="med"/>
-                    </a:lnL>
-                    <a:lnR w="9525" cap="flat" cmpd="sng" algn="ctr">
-                      <a:solidFill>
-                        <a:srgbClr val="1F2733"/>
-                      </a:solidFill>
-                      <a:prstDash val="solid"/>
-                      <a:round/>
-                      <a:headEnd type="none" w="med" len="med"/>
-                      <a:tailEnd type="none" w="med" len="med"/>
-                    </a:lnR>
-                    <a:lnT w="9525" cap="flat" cmpd="sng" algn="ctr">
-                      <a:solidFill>
-                        <a:srgbClr val="1F2733"/>
-                      </a:solidFill>
-                      <a:prstDash val="solid"/>
-                      <a:round/>
-                      <a:headEnd type="none" w="med" len="med"/>
-                      <a:tailEnd type="none" w="med" len="med"/>
-                    </a:lnT>
-                    <a:lnB w="9525" cap="flat" cmpd="sng" algn="ctr">
-                      <a:solidFill>
-                        <a:srgbClr val="1F2733"/>
-                      </a:solidFill>
-                      <a:prstDash val="solid"/>
-                      <a:round/>
-                      <a:headEnd type="none" w="med" len="med"/>
-                      <a:tailEnd type="none" w="med" len="med"/>
-                    </a:lnB>
-                  </a:tcPr>
-                </a:tc>
-                <a:tc>
-                  <a:txBody>
-                    <a:bodyPr/>
-                    <a:lstStyle/>
-                    <a:p>
-                      <a:pPr algn="r" indent="0" marL="0">
-                        <a:buNone/>
-                      </a:pPr>
-                      <a:r>
-                        <a:rPr lang="en-US" sz="1200" dirty="0">
-                          <a:solidFill>
-                            <a:srgbClr val="EEF2F6"/>
-                          </a:solidFill>
-                          <a:latin typeface="Courier New" pitchFamily="34" charset="0"/>
-                          <a:ea typeface="Courier New" pitchFamily="34" charset="-122"/>
-                          <a:cs typeface="Courier New" pitchFamily="34" charset="-120"/>
-                        </a:rPr>
-                        <a:t>—</a:t>
-                      </a:r>
-                      <a:endParaRPr lang="en-US" sz="1200" dirty="0">
-                        <a:latin typeface="Courier New" charset="0"/>
-                        <a:ea typeface="Courier New" charset="0"/>
-                        <a:cs typeface="Courier New" charset="0"/>
-                      </a:endParaRPr>
-                    </a:p>
-                  </a:txBody>
-                  <a:tcPr marL="63500" marR="63500" marT="0" marB="0" anchor="ctr">
-                    <a:lnL w="9525" cap="flat" cmpd="sng" algn="ctr">
-                      <a:solidFill>
-                        <a:srgbClr val="1F2733"/>
-                      </a:solidFill>
-                      <a:prstDash val="solid"/>
-                      <a:round/>
-                      <a:headEnd type="none" w="med" len="med"/>
-                      <a:tailEnd type="none" w="med" len="med"/>
-                    </a:lnL>
-                    <a:lnR w="9525" cap="flat" cmpd="sng" algn="ctr">
-                      <a:solidFill>
-                        <a:srgbClr val="1F2733"/>
-                      </a:solidFill>
-                      <a:prstDash val="solid"/>
-                      <a:round/>
-                      <a:headEnd type="none" w="med" len="med"/>
-                      <a:tailEnd type="none" w="med" len="med"/>
-                    </a:lnR>
-                    <a:lnT w="9525" cap="flat" cmpd="sng" algn="ctr">
-                      <a:solidFill>
-                        <a:srgbClr val="1F2733"/>
-                      </a:solidFill>
-                      <a:prstDash val="solid"/>
-                      <a:round/>
-                      <a:headEnd type="none" w="med" len="med"/>
-                      <a:tailEnd type="none" w="med" len="med"/>
-                    </a:lnT>
-                    <a:lnB w="9525" cap="flat" cmpd="sng" algn="ctr">
-                      <a:solidFill>
-                        <a:srgbClr val="1F2733"/>
-                      </a:solidFill>
-                      <a:prstDash val="solid"/>
-                      <a:round/>
-                      <a:headEnd type="none" w="med" len="med"/>
-                      <a:tailEnd type="none" w="med" len="med"/>
-                    </a:lnB>
-                  </a:tcPr>
-                </a:tc>
-                <a:tc>
-                  <a:txBody>
-                    <a:bodyPr/>
-                    <a:lstStyle/>
-                    <a:p>
-                      <a:pPr algn="r" indent="0" marL="0">
-                        <a:buNone/>
-                      </a:pPr>
-                      <a:r>
-                        <a:rPr lang="en-US" sz="1200" dirty="0">
-                          <a:solidFill>
-                            <a:srgbClr val="EEF2F6"/>
-                          </a:solidFill>
-                          <a:latin typeface="Courier New" pitchFamily="34" charset="0"/>
-                          <a:ea typeface="Courier New" pitchFamily="34" charset="-122"/>
-                          <a:cs typeface="Courier New" pitchFamily="34" charset="-120"/>
-                        </a:rPr>
-                        <a:t>2</a:t>
-                      </a:r>
-                      <a:endParaRPr lang="en-US" sz="1200" dirty="0">
-                        <a:latin typeface="Courier New" charset="0"/>
-                        <a:ea typeface="Courier New" charset="0"/>
-                        <a:cs typeface="Courier New" charset="0"/>
-                      </a:endParaRPr>
-                    </a:p>
-                  </a:txBody>
-                  <a:tcPr marL="63500" marR="63500" marT="0" marB="0" anchor="ctr">
-                    <a:lnL w="9525" cap="flat" cmpd="sng" algn="ctr">
-                      <a:solidFill>
-                        <a:srgbClr val="1F2733"/>
-                      </a:solidFill>
-                      <a:prstDash val="solid"/>
-                      <a:round/>
-                      <a:headEnd type="none" w="med" len="med"/>
-                      <a:tailEnd type="none" w="med" len="med"/>
-                    </a:lnL>
-                    <a:lnR w="9525" cap="flat" cmpd="sng" algn="ctr">
-                      <a:solidFill>
-                        <a:srgbClr val="1F2733"/>
-                      </a:solidFill>
-                      <a:prstDash val="solid"/>
-                      <a:round/>
-                      <a:headEnd type="none" w="med" len="med"/>
-                      <a:tailEnd type="none" w="med" len="med"/>
-                    </a:lnR>
-                    <a:lnT w="9525" cap="flat" cmpd="sng" algn="ctr">
-                      <a:solidFill>
-                        <a:srgbClr val="1F2733"/>
-                      </a:solidFill>
-                      <a:prstDash val="solid"/>
-                      <a:round/>
-                      <a:headEnd type="none" w="med" len="med"/>
-                      <a:tailEnd type="none" w="med" len="med"/>
-                    </a:lnT>
-                    <a:lnB w="9525" cap="flat" cmpd="sng" algn="ctr">
-                      <a:solidFill>
-                        <a:srgbClr val="1F2733"/>
-                      </a:solidFill>
-                      <a:prstDash val="solid"/>
-                      <a:round/>
-                      <a:headEnd type="none" w="med" len="med"/>
-                      <a:tailEnd type="none" w="med" len="med"/>
-                    </a:lnB>
-                  </a:tcPr>
-                </a:tc>
-                <a:tc>
-                  <a:txBody>
-                    <a:bodyPr/>
-                    <a:lstStyle/>
-                    <a:p>
-                      <a:pPr algn="r" indent="0" marL="0">
-                        <a:buNone/>
-                      </a:pPr>
-                      <a:r>
-                        <a:rPr lang="en-US" sz="1200" dirty="0">
-                          <a:solidFill>
-                            <a:srgbClr val="EEF2F6"/>
-                          </a:solidFill>
-                          <a:latin typeface="Courier New" pitchFamily="34" charset="0"/>
-                          <a:ea typeface="Courier New" pitchFamily="34" charset="-122"/>
-                          <a:cs typeface="Courier New" pitchFamily="34" charset="-120"/>
-                        </a:rPr>
-                        <a:t>25%</a:t>
-                      </a:r>
-                      <a:endParaRPr lang="en-US" sz="1200" dirty="0">
-                        <a:latin typeface="Courier New" charset="0"/>
-                        <a:ea typeface="Courier New" charset="0"/>
-                        <a:cs typeface="Courier New" charset="0"/>
-                      </a:endParaRPr>
-                    </a:p>
-                  </a:txBody>
-                  <a:tcPr marL="63500" marR="63500" marT="0" marB="0" anchor="ctr">
-                    <a:lnL w="9525" cap="flat" cmpd="sng" algn="ctr">
-                      <a:solidFill>
-                        <a:srgbClr val="1F2733"/>
-                      </a:solidFill>
-                      <a:prstDash val="solid"/>
-                      <a:round/>
-                      <a:headEnd type="none" w="med" len="med"/>
-                      <a:tailEnd type="none" w="med" len="med"/>
-                    </a:lnL>
-                    <a:lnR w="9525" cap="flat" cmpd="sng" algn="ctr">
-                      <a:solidFill>
-                        <a:srgbClr val="1F2733"/>
-                      </a:solidFill>
-                      <a:prstDash val="solid"/>
-                      <a:round/>
-                      <a:headEnd type="none" w="med" len="med"/>
-                      <a:tailEnd type="none" w="med" len="med"/>
-                    </a:lnR>
-                    <a:lnT w="9525" cap="flat" cmpd="sng" algn="ctr">
-                      <a:solidFill>
-                        <a:srgbClr val="1F2733"/>
-                      </a:solidFill>
-                      <a:prstDash val="solid"/>
-                      <a:round/>
-                      <a:headEnd type="none" w="med" len="med"/>
-                      <a:tailEnd type="none" w="med" len="med"/>
-                    </a:lnT>
-                    <a:lnB w="9525" cap="flat" cmpd="sng" algn="ctr">
-                      <a:solidFill>
-                        <a:srgbClr val="1F2733"/>
-                      </a:solidFill>
-                      <a:prstDash val="solid"/>
-                      <a:round/>
-                      <a:headEnd type="none" w="med" len="med"/>
-                      <a:tailEnd type="none" w="med" len="med"/>
-                    </a:lnB>
-                  </a:tcPr>
-                </a:tc>
-              </a:tr>
-            </a:tbl>
-          </a:graphicData>
-        </a:graphic>
-      </p:graphicFrame>
-      <p:sp>
-        <p:nvSpPr>
-          <p:cNvPr id="22" name="Activity panel"/>
+      <p:sp>
+        <p:nvSpPr>
+          <p:cNvPr id="11" name="Point 3"/>
+          <p:cNvSpPr txBox="1"/>
+          <p:nvPr/>
+        </p:nvSpPr>
+        <p:spPr>
+          <a:xfrm>
+            <a:off x="1054100" y="4889500"/>
+            <a:ext cx="2552700" cy="254000"/>
+          </a:xfrm>
+          <a:prstGeom prst="rect">
+            <a:avLst/>
+          </a:prstGeom>
+          <a:noFill/>
+          <a:ln/>
+        </p:spPr>
+        <p:txBody>
+          <a:bodyPr wrap="square" lIns="0" tIns="0" rIns="0" bIns="0" rtlCol="0" anchor="t"/>
+          <a:lstStyle/>
+          <a:p>
+            <a:pPr algn="l" indent="0" marL="0">
+              <a:buNone/>
+            </a:pPr>
+            <a:r>
+              <a:rPr lang="en-US" sz="1500" b="1" dirty="0">
+                <a:solidFill>
+                  <a:srgbClr val="EEF2F6"/>
+                </a:solidFill>
+              </a:rPr>
+              <a:t>Stage bar</a:t>
+            </a:r>
+            <a:endParaRPr lang="en-US" sz="1500" dirty="0"/>
+          </a:p>
+        </p:txBody>
+      </p:sp>
+      <p:sp>
+        <p:nvSpPr>
+          <p:cNvPr id="12" name="Point 3 detail"/>
+          <p:cNvSpPr txBox="1"/>
+          <p:nvPr/>
+        </p:nvSpPr>
+        <p:spPr>
+          <a:xfrm>
+            <a:off x="1054100" y="5168900"/>
+            <a:ext cx="2552700" cy="571500"/>
+          </a:xfrm>
+          <a:prstGeom prst="rect">
+            <a:avLst/>
+          </a:prstGeom>
+          <a:noFill/>
+          <a:ln/>
+        </p:spPr>
+        <p:txBody>
+          <a:bodyPr wrap="square" lIns="0" tIns="0" rIns="0" bIns="0" rtlCol="0" anchor="t"/>
+          <a:lstStyle/>
+          <a:p>
+            <a:pPr algn="l" indent="0" marL="0">
+              <a:lnSpc>
+                <a:spcPct val="125000"/>
+              </a:lnSpc>
+              <a:buNone/>
+            </a:pPr>
+            <a:r>
+              <a:rPr lang="en-US" sz="1200" dirty="0">
+                <a:solidFill>
+                  <a:srgbClr val="9AA8BA"/>
+                </a:solidFill>
+              </a:rPr>
+              <a:t>Walks judges through the five demo acts, one click each</a:t>
+            </a:r>
+            <a:endParaRPr lang="en-US" sz="1200" dirty="0"/>
+          </a:p>
+        </p:txBody>
+      </p:sp>
+      <p:sp>
+        <p:nvSpPr>
+          <p:cNvPr id="13" name="Screenshot frame"/>
           <p:cNvSpPr/>
           <p:nvPr/>
         </p:nvSpPr>
         <p:spPr>
           <a:xfrm>
-            <a:off x="7061200" y="2476500"/>
-            <a:ext cx="4318000" cy="3302000"/>
+            <a:off x="3898900" y="939800"/>
+            <a:ext cx="7518400" cy="4730750"/>
           </a:xfrm>
           <a:prstGeom prst="roundRect">
             <a:avLst>
-              <a:gd name="adj" fmla="val 3077"/>
+              <a:gd name="adj" fmla="val 1879"/>
             </a:avLst>
           </a:prstGeom>
           <a:solidFill>
-            <a:srgbClr val="0E1218"/>
+            <a:srgbClr val="1F2733"/>
           </a:solidFill>
-          <a:ln w="9525">
-            <a:solidFill>
-              <a:srgbClr val="1F2733"/>
-            </a:solidFill>
-            <a:prstDash val="solid"/>
-          </a:ln>
-        </p:spPr>
-      </p:sp>
-      <p:sp>
-        <p:nvSpPr>
-          <p:cNvPr id="23" name="Text 20"/>
+          <a:ln/>
+        </p:spPr>
+      </p:sp>
+      <p:pic>
+        <p:nvPicPr>
+          <p:cNvPr id="14" name="Dashboard screenshot" descr="KRIYA mission control dashboard on Ethereum Sepolia after a Claude-driven rebalance: six-step loop pipeline, latest decision, risk chart, activity timeline, and the demo stage bar at Done">    </p:cNvPr>
+          <p:cNvPicPr>
+            <a:picLocks noChangeAspect="1"/>
+          </p:cNvPicPr>
+          <p:nvPr/>
+        </p:nvPicPr>
+        <p:blipFill>
+          <a:blip r:embed="rId1"/>
+          <a:stretch>
+            <a:fillRect/>
+          </a:stretch>
+        </p:blipFill>
+        <p:spPr>
+          <a:xfrm>
+            <a:off x="3937000" y="977900"/>
+            <a:ext cx="7442200" cy="4654550"/>
+          </a:xfrm>
+          <a:prstGeom prst="rect">
+            <a:avLst/>
+          </a:prstGeom>
+        </p:spPr>
+      </p:pic>
+      <p:sp>
+        <p:nvSpPr>
+          <p:cNvPr id="15" name="Caption"/>
           <p:cNvSpPr txBox="1"/>
           <p:nvPr/>
         </p:nvSpPr>
         <p:spPr>
           <a:xfrm>
-            <a:off x="7264400" y="2654300"/>
-            <a:ext cx="3911600" cy="215900"/>
+            <a:off x="3937000" y="5772150"/>
+            <a:ext cx="7442200" cy="254000"/>
           </a:xfrm>
           <a:prstGeom prst="rect">
             <a:avLst/>
@@ -14503,265 +12934,14 @@
               <a:buNone/>
             </a:pPr>
             <a:r>
-              <a:rPr lang="en-US" sz="1200" dirty="0">
-                <a:solidFill>
-                  <a:srgbClr val="8592A6"/>
-                </a:solidFill>
-              </a:rPr>
-              <a:t>KRIYA activity</a:t>
-            </a:r>
-            <a:endParaRPr lang="en-US" sz="1200" dirty="0"/>
-          </a:p>
-        </p:txBody>
-      </p:sp>
-      <p:sp>
-        <p:nvSpPr>
-          <p:cNvPr id="24" name="Text 21"/>
-          <p:cNvSpPr txBox="1"/>
-          <p:nvPr/>
-        </p:nvSpPr>
-        <p:spPr>
-          <a:xfrm>
-            <a:off x="7264400" y="3048000"/>
-            <a:ext cx="3911600" cy="444500"/>
-          </a:xfrm>
-          <a:prstGeom prst="rect">
-            <a:avLst/>
-          </a:prstGeom>
-          <a:noFill/>
-          <a:ln/>
-        </p:spPr>
-        <p:txBody>
-          <a:bodyPr wrap="square" lIns="0" tIns="0" rIns="0" bIns="0" rtlCol="0" anchor="t"/>
-          <a:lstStyle/>
-          <a:p>
-            <a:pPr algn="l" indent="0" marL="0">
-              <a:lnSpc>
-                <a:spcPct val="120000"/>
-              </a:lnSpc>
-              <a:buNone/>
-            </a:pPr>
-            <a:r>
-              <a:rPr lang="en-US" sz="1200" dirty="0">
-                <a:solidFill>
-                  <a:srgbClr val="7CF7C4"/>
-                </a:solidFill>
-              </a:rPr>
-              <a:t>⚡  </a:t>
-            </a:r>
-            <a:pPr algn="l" indent="0" marL="0">
-              <a:lnSpc>
-                <a:spcPct val="120000"/>
-              </a:lnSpc>
-              <a:buNone/>
-            </a:pPr>
-            <a:r>
-              <a:rPr lang="en-US" sz="1200" dirty="0">
-                <a:solidFill>
-                  <a:srgbClr val="EEF2F6"/>
-                </a:solidFill>
-              </a:rPr>
-              <a:t>CRE rebalance · Claude decision</a:t>
-            </a:r>
-            <a:endParaRPr lang="en-US" sz="1200" dirty="0"/>
-          </a:p>
-        </p:txBody>
-      </p:sp>
-      <p:sp>
-        <p:nvSpPr>
-          <p:cNvPr id="25" name="Text 22"/>
-          <p:cNvSpPr txBox="1"/>
-          <p:nvPr/>
-        </p:nvSpPr>
-        <p:spPr>
-          <a:xfrm>
-            <a:off x="7264400" y="3619500"/>
-            <a:ext cx="3911600" cy="444500"/>
-          </a:xfrm>
-          <a:prstGeom prst="rect">
-            <a:avLst/>
-          </a:prstGeom>
-          <a:noFill/>
-          <a:ln/>
-        </p:spPr>
-        <p:txBody>
-          <a:bodyPr wrap="square" lIns="0" tIns="0" rIns="0" bIns="0" rtlCol="0" anchor="t"/>
-          <a:lstStyle/>
-          <a:p>
-            <a:pPr algn="l" indent="0" marL="0">
-              <a:lnSpc>
-                <a:spcPct val="120000"/>
-              </a:lnSpc>
-              <a:buNone/>
-            </a:pPr>
-            <a:r>
-              <a:rPr lang="en-US" sz="1200" dirty="0">
-                <a:solidFill>
-                  <a:srgbClr val="FFB547"/>
-                </a:solidFill>
-              </a:rPr>
-              <a:t>⚠  </a:t>
-            </a:r>
-            <a:pPr algn="l" indent="0" marL="0">
-              <a:lnSpc>
-                <a:spcPct val="120000"/>
-              </a:lnSpc>
-              <a:buNone/>
-            </a:pPr>
-            <a:r>
-              <a:rPr lang="en-US" sz="1200" dirty="0">
-                <a:solidFill>
-                  <a:srgbClr val="EEF2F6"/>
-                </a:solidFill>
-              </a:rPr>
-              <a:t>Verified risk: B 34 → 48</a:t>
-            </a:r>
-            <a:endParaRPr lang="en-US" sz="1200" dirty="0"/>
-          </a:p>
-        </p:txBody>
-      </p:sp>
-      <p:sp>
-        <p:nvSpPr>
-          <p:cNvPr id="26" name="Text 23"/>
-          <p:cNvSpPr txBox="1"/>
-          <p:nvPr/>
-        </p:nvSpPr>
-        <p:spPr>
-          <a:xfrm>
-            <a:off x="7264400" y="4191000"/>
-            <a:ext cx="3911600" cy="444500"/>
-          </a:xfrm>
-          <a:prstGeom prst="rect">
-            <a:avLst/>
-          </a:prstGeom>
-          <a:noFill/>
-          <a:ln/>
-        </p:spPr>
-        <p:txBody>
-          <a:bodyPr wrap="square" lIns="0" tIns="0" rIns="0" bIns="0" rtlCol="0" anchor="t"/>
-          <a:lstStyle/>
-          <a:p>
-            <a:pPr algn="l" indent="0" marL="0">
-              <a:lnSpc>
-                <a:spcPct val="120000"/>
-              </a:lnSpc>
-              <a:buNone/>
-            </a:pPr>
-            <a:r>
-              <a:rPr lang="en-US" sz="1200" dirty="0">
-                <a:solidFill>
-                  <a:srgbClr val="FF5D6C"/>
-                </a:solidFill>
-              </a:rPr>
-              <a:t>✗  </a:t>
-            </a:r>
-            <a:pPr algn="l" indent="0" marL="0">
-              <a:lnSpc>
-                <a:spcPct val="120000"/>
-              </a:lnSpc>
-              <a:buNone/>
-            </a:pPr>
-            <a:r>
-              <a:rPr lang="en-US" sz="1200" dirty="0">
-                <a:solidFill>
-                  <a:srgbClr val="EEF2F6"/>
-                </a:solidFill>
-              </a:rPr>
-              <a:t>Unsafe 60% proposal reverted</a:t>
-            </a:r>
-            <a:endParaRPr lang="en-US" sz="1200" dirty="0"/>
-          </a:p>
-        </p:txBody>
-      </p:sp>
-      <p:sp>
-        <p:nvSpPr>
-          <p:cNvPr id="27" name="Text 24"/>
-          <p:cNvSpPr txBox="1"/>
-          <p:nvPr/>
-        </p:nvSpPr>
-        <p:spPr>
-          <a:xfrm>
-            <a:off x="7264400" y="4762500"/>
-            <a:ext cx="3911600" cy="444500"/>
-          </a:xfrm>
-          <a:prstGeom prst="rect">
-            <a:avLst/>
-          </a:prstGeom>
-          <a:noFill/>
-          <a:ln/>
-        </p:spPr>
-        <p:txBody>
-          <a:bodyPr wrap="square" lIns="0" tIns="0" rIns="0" bIns="0" rtlCol="0" anchor="t"/>
-          <a:lstStyle/>
-          <a:p>
-            <a:pPr algn="l" indent="0" marL="0">
-              <a:lnSpc>
-                <a:spcPct val="120000"/>
-              </a:lnSpc>
-              <a:buNone/>
-            </a:pPr>
-            <a:r>
-              <a:rPr lang="en-US" sz="1200" dirty="0">
-                <a:solidFill>
-                  <a:srgbClr val="7CF7C4"/>
-                </a:solidFill>
-              </a:rPr>
-              <a:t>◆  </a:t>
-            </a:r>
-            <a:pPr algn="l" indent="0" marL="0">
-              <a:lnSpc>
-                <a:spcPct val="120000"/>
-              </a:lnSpc>
-              <a:buNone/>
-            </a:pPr>
-            <a:r>
-              <a:rPr lang="en-US" sz="1200" dirty="0">
-                <a:solidFill>
-                  <a:srgbClr val="EEF2F6"/>
-                </a:solidFill>
-              </a:rPr>
-              <a:t>Mandate active · KRIYA authorized</a:t>
-            </a:r>
-            <a:endParaRPr lang="en-US" sz="1200" dirty="0"/>
-          </a:p>
-        </p:txBody>
-      </p:sp>
-      <p:sp>
-        <p:nvSpPr>
-          <p:cNvPr id="28" name="Footer"/>
-          <p:cNvSpPr txBox="1"/>
-          <p:nvPr/>
-        </p:nvSpPr>
-        <p:spPr>
-          <a:xfrm>
-            <a:off x="812800" y="6045200"/>
-            <a:ext cx="10566400" cy="254000"/>
-          </a:xfrm>
-          <a:prstGeom prst="rect">
-            <a:avLst/>
-          </a:prstGeom>
-          <a:noFill/>
-          <a:ln/>
-        </p:spPr>
-        <p:txBody>
-          <a:bodyPr wrap="square" lIns="0" tIns="0" rIns="0" bIns="0" rtlCol="0" anchor="t"/>
-          <a:lstStyle/>
-          <a:p>
-            <a:pPr algn="l" indent="0" marL="0">
-              <a:buNone/>
-            </a:pPr>
-            <a:r>
-              <a:rPr lang="en-US" sz="1200" dirty="0">
+              <a:rPr lang="en-US" sz="1100" dirty="0">
                 <a:solidFill>
                   <a:srgbClr val="6B7A8F"/>
                 </a:solidFill>
-                <a:latin typeface="Courier New" pitchFamily="34" charset="0"/>
-                <a:ea typeface="Courier New" pitchFamily="34" charset="-122"/>
-                <a:cs typeface="Courier New" pitchFamily="34" charset="-120"/>
-              </a:rPr>
-              <a:t>Rebuilt from the live Sepolia state at kriya-beta.vercel.app · every activity row links to its transaction</a:t>
-            </a:r>
-            <a:endParaRPr lang="en-US" sz="1200" dirty="0"/>
+              </a:rPr>
+              <a:t>Live on Sepolia · kriya-beta.vercel.app · right after Claude exited a strategy that breached the mandate</a:t>
+            </a:r>
+            <a:endParaRPr lang="en-US" sz="1100" dirty="0"/>
           </a:p>
         </p:txBody>
       </p:sp>

</xml_diff>